<commit_message>
Add Thank You slide to portfolio presentation
</commit_message>
<xml_diff>
--- a/Anugrah_Data_Analytics_Internship_Portfolio.pptx
+++ b/Anugrah_Data_Analytics_Internship_Portfolio.pptx
@@ -2,7 +2,7 @@
 <file path=ppt/presentation.xml><?xml version="1.0" encoding="utf-8"?>
 <p:presentation xmlns:a="http://schemas.openxmlformats.org/drawingml/2006/main" xmlns:r="http://schemas.openxmlformats.org/officeDocument/2006/relationships" xmlns:p="http://schemas.openxmlformats.org/presentationml/2006/main" saveSubsetFonts="1" autoCompressPictures="0">
   <p:sldMasterIdLst>
-    <p:sldMasterId id="2147483648" r:id="rId1"/>
+    <p:sldMasterId id="2147483660" r:id="rId1"/>
   </p:sldMasterIdLst>
   <p:sldIdLst>
     <p:sldId id="256" r:id="rId2"/>
@@ -13,6 +13,7 @@
     <p:sldId id="261" r:id="rId7"/>
     <p:sldId id="262" r:id="rId8"/>
     <p:sldId id="263" r:id="rId9"/>
+    <p:sldId id="264" r:id="rId10"/>
   </p:sldIdLst>
   <p:sldSz cx="12192000" cy="6858000"/>
   <p:notesSz cx="6858000" cy="9144000"/>
@@ -159,19 +160,25 @@
         </p:nvSpPr>
         <p:spPr>
           <a:xfrm>
-            <a:off x="685800" y="2130425"/>
-            <a:ext cx="7772400" cy="1470025"/>
-          </a:xfrm>
-        </p:spPr>
-        <p:txBody>
-          <a:bodyPr/>
-          <a:lstStyle/>
+            <a:off x="1595269" y="1122363"/>
+            <a:ext cx="9001462" cy="2387600"/>
+          </a:xfrm>
+        </p:spPr>
+        <p:txBody>
+          <a:bodyPr anchor="b">
+            <a:normAutofit/>
+          </a:bodyPr>
+          <a:lstStyle>
+            <a:lvl1pPr algn="ctr">
+              <a:defRPr sz="4800"/>
+            </a:lvl1pPr>
+          </a:lstStyle>
           <a:p>
             <a:r>
               <a:rPr lang="en-US" smtClean="0"/>
               <a:t>Click to edit Master title style</a:t>
             </a:r>
-            <a:endParaRPr lang="en-US"/>
+            <a:endParaRPr lang="en-US" dirty="0"/>
           </a:p>
         </p:txBody>
       </p:sp>
@@ -187,8 +194,8 @@
         </p:nvSpPr>
         <p:spPr>
           <a:xfrm>
-            <a:off x="1371600" y="3886200"/>
-            <a:ext cx="6400800" cy="1752600"/>
+            <a:off x="1595269" y="3602038"/>
+            <a:ext cx="9001462" cy="1655762"/>
           </a:xfrm>
         </p:spPr>
         <p:txBody>
@@ -196,93 +203,39 @@
           <a:lstStyle>
             <a:lvl1pPr marL="0" indent="0" algn="ctr">
               <a:buNone/>
-              <a:defRPr>
-                <a:solidFill>
-                  <a:schemeClr val="tx1">
-                    <a:tint val="75000"/>
-                  </a:schemeClr>
-                </a:solidFill>
-              </a:defRPr>
+              <a:defRPr sz="2400"/>
             </a:lvl1pPr>
             <a:lvl2pPr marL="457200" indent="0" algn="ctr">
               <a:buNone/>
-              <a:defRPr>
-                <a:solidFill>
-                  <a:schemeClr val="tx1">
-                    <a:tint val="75000"/>
-                  </a:schemeClr>
-                </a:solidFill>
-              </a:defRPr>
+              <a:defRPr sz="2000"/>
             </a:lvl2pPr>
             <a:lvl3pPr marL="914400" indent="0" algn="ctr">
               <a:buNone/>
-              <a:defRPr>
-                <a:solidFill>
-                  <a:schemeClr val="tx1">
-                    <a:tint val="75000"/>
-                  </a:schemeClr>
-                </a:solidFill>
-              </a:defRPr>
+              <a:defRPr sz="1800"/>
             </a:lvl3pPr>
             <a:lvl4pPr marL="1371600" indent="0" algn="ctr">
               <a:buNone/>
-              <a:defRPr>
-                <a:solidFill>
-                  <a:schemeClr val="tx1">
-                    <a:tint val="75000"/>
-                  </a:schemeClr>
-                </a:solidFill>
-              </a:defRPr>
+              <a:defRPr sz="1600"/>
             </a:lvl4pPr>
             <a:lvl5pPr marL="1828800" indent="0" algn="ctr">
               <a:buNone/>
-              <a:defRPr>
-                <a:solidFill>
-                  <a:schemeClr val="tx1">
-                    <a:tint val="75000"/>
-                  </a:schemeClr>
-                </a:solidFill>
-              </a:defRPr>
+              <a:defRPr sz="1600"/>
             </a:lvl5pPr>
             <a:lvl6pPr marL="2286000" indent="0" algn="ctr">
               <a:buNone/>
-              <a:defRPr>
-                <a:solidFill>
-                  <a:schemeClr val="tx1">
-                    <a:tint val="75000"/>
-                  </a:schemeClr>
-                </a:solidFill>
-              </a:defRPr>
+              <a:defRPr sz="1600"/>
             </a:lvl6pPr>
             <a:lvl7pPr marL="2743200" indent="0" algn="ctr">
               <a:buNone/>
-              <a:defRPr>
-                <a:solidFill>
-                  <a:schemeClr val="tx1">
-                    <a:tint val="75000"/>
-                  </a:schemeClr>
-                </a:solidFill>
-              </a:defRPr>
+              <a:defRPr sz="1600"/>
             </a:lvl7pPr>
             <a:lvl8pPr marL="3200400" indent="0" algn="ctr">
               <a:buNone/>
-              <a:defRPr>
-                <a:solidFill>
-                  <a:schemeClr val="tx1">
-                    <a:tint val="75000"/>
-                  </a:schemeClr>
-                </a:solidFill>
-              </a:defRPr>
+              <a:defRPr sz="1600"/>
             </a:lvl8pPr>
             <a:lvl9pPr marL="3657600" indent="0" algn="ctr">
               <a:buNone/>
-              <a:defRPr>
-                <a:solidFill>
-                  <a:schemeClr val="tx1">
-                    <a:tint val="75000"/>
-                  </a:schemeClr>
-                </a:solidFill>
-              </a:defRPr>
+              <a:defRPr sz="1600"/>
             </a:lvl9pPr>
           </a:lstStyle>
           <a:p>
@@ -290,7 +243,7 @@
               <a:rPr lang="en-US" smtClean="0"/>
               <a:t>Click to edit Master subtitle style</a:t>
             </a:r>
-            <a:endParaRPr lang="en-US"/>
+            <a:endParaRPr lang="en-US" dirty="0"/>
           </a:p>
         </p:txBody>
       </p:sp>
@@ -311,7 +264,7 @@
           <a:p>
             <a:fld id="{5BCAD085-E8A6-8845-BD4E-CB4CCA059FC4}" type="datetimeFigureOut">
               <a:rPr lang="en-US" smtClean="0"/>
-              <a:t>10/4/2026</a:t>
+              <a:t>10/8/2026</a:t>
             </a:fld>
             <a:endParaRPr lang="en-US"/>
           </a:p>
@@ -362,7 +315,7 @@
     </p:spTree>
     <p:extLst>
       <p:ext uri="{BB962C8B-B14F-4D97-AF65-F5344CB8AC3E}">
-        <p14:creationId xmlns:p14="http://schemas.microsoft.com/office/powerpoint/2010/main" val="3168075583"/>
+        <p14:creationId xmlns:p14="http://schemas.microsoft.com/office/powerpoint/2010/main" val="1489462750"/>
       </p:ext>
     </p:extLst>
   </p:cSld>
@@ -373,6 +326,2556 @@
 </file>
 
 <file path=ppt/slideLayouts/slideLayout10.xml><?xml version="1.0" encoding="utf-8"?>
+<p:sldLayout xmlns:a="http://schemas.openxmlformats.org/drawingml/2006/main" xmlns:r="http://schemas.openxmlformats.org/officeDocument/2006/relationships" xmlns:p="http://schemas.openxmlformats.org/presentationml/2006/main" preserve="1">
+  <p:cSld name="Panoramic Picture with Caption">
+    <p:spTree>
+      <p:nvGrpSpPr>
+        <p:cNvPr id="1" name=""/>
+        <p:cNvGrpSpPr/>
+        <p:nvPr/>
+      </p:nvGrpSpPr>
+      <p:grpSpPr>
+        <a:xfrm>
+          <a:off x="0" y="0"/>
+          <a:ext cx="0" cy="0"/>
+          <a:chOff x="0" y="0"/>
+          <a:chExt cx="0" cy="0"/>
+        </a:xfrm>
+      </p:grpSpPr>
+      <p:sp>
+        <p:nvSpPr>
+          <p:cNvPr id="2" name="Title 1"/>
+          <p:cNvSpPr>
+            <a:spLocks noGrp="1"/>
+          </p:cNvSpPr>
+          <p:nvPr>
+            <p:ph type="title"/>
+          </p:nvPr>
+        </p:nvSpPr>
+        <p:spPr>
+          <a:xfrm>
+            <a:off x="913806" y="4289372"/>
+            <a:ext cx="10367564" cy="819355"/>
+          </a:xfrm>
+        </p:spPr>
+        <p:txBody>
+          <a:bodyPr anchor="b">
+            <a:normAutofit/>
+          </a:bodyPr>
+          <a:lstStyle>
+            <a:lvl1pPr>
+              <a:defRPr sz="2800"/>
+            </a:lvl1pPr>
+          </a:lstStyle>
+          <a:p>
+            <a:r>
+              <a:rPr lang="en-US" smtClean="0"/>
+              <a:t>Click to edit Master title style</a:t>
+            </a:r>
+            <a:endParaRPr lang="en-US" dirty="0"/>
+          </a:p>
+        </p:txBody>
+      </p:sp>
+      <p:sp>
+        <p:nvSpPr>
+          <p:cNvPr id="3" name="Picture Placeholder 2"/>
+          <p:cNvSpPr>
+            <a:spLocks noGrp="1" noChangeAspect="1"/>
+          </p:cNvSpPr>
+          <p:nvPr>
+            <p:ph type="pic" idx="1"/>
+          </p:nvPr>
+        </p:nvSpPr>
+        <p:spPr>
+          <a:xfrm>
+            <a:off x="913806" y="621321"/>
+            <a:ext cx="10367564" cy="3379735"/>
+          </a:xfrm>
+          <a:noFill/>
+          <a:ln w="190500" cap="sq">
+            <a:solidFill>
+              <a:srgbClr val="FFFFFF"/>
+            </a:solidFill>
+            <a:miter lim="800000"/>
+          </a:ln>
+          <a:effectLst>
+            <a:outerShdw blurRad="55000" dist="18000" dir="5400000" algn="tl" rotWithShape="0">
+              <a:srgbClr val="000000">
+                <a:alpha val="40000"/>
+              </a:srgbClr>
+            </a:outerShdw>
+          </a:effectLst>
+          <a:scene3d>
+            <a:camera prst="orthographicFront"/>
+            <a:lightRig rig="twoPt" dir="t">
+              <a:rot lat="0" lon="0" rev="7200000"/>
+            </a:lightRig>
+          </a:scene3d>
+          <a:sp3d>
+            <a:bevelT w="25400" h="19050"/>
+            <a:contourClr>
+              <a:srgbClr val="FFFFFF"/>
+            </a:contourClr>
+          </a:sp3d>
+        </p:spPr>
+        <p:txBody>
+          <a:bodyPr anchor="t"/>
+          <a:lstStyle>
+            <a:lvl1pPr marL="0" indent="0" algn="ctr">
+              <a:buNone/>
+              <a:defRPr sz="3200"/>
+            </a:lvl1pPr>
+            <a:lvl2pPr marL="457200" indent="0">
+              <a:buNone/>
+              <a:defRPr sz="2800"/>
+            </a:lvl2pPr>
+            <a:lvl3pPr marL="914400" indent="0">
+              <a:buNone/>
+              <a:defRPr sz="2400"/>
+            </a:lvl3pPr>
+            <a:lvl4pPr marL="1371600" indent="0">
+              <a:buNone/>
+              <a:defRPr sz="2000"/>
+            </a:lvl4pPr>
+            <a:lvl5pPr marL="1828800" indent="0">
+              <a:buNone/>
+              <a:defRPr sz="2000"/>
+            </a:lvl5pPr>
+            <a:lvl6pPr marL="2286000" indent="0">
+              <a:buNone/>
+              <a:defRPr sz="2000"/>
+            </a:lvl6pPr>
+            <a:lvl7pPr marL="2743200" indent="0">
+              <a:buNone/>
+              <a:defRPr sz="2000"/>
+            </a:lvl7pPr>
+            <a:lvl8pPr marL="3200400" indent="0">
+              <a:buNone/>
+              <a:defRPr sz="2000"/>
+            </a:lvl8pPr>
+            <a:lvl9pPr marL="3657600" indent="0">
+              <a:buNone/>
+              <a:defRPr sz="2000"/>
+            </a:lvl9pPr>
+          </a:lstStyle>
+          <a:p>
+            <a:r>
+              <a:rPr lang="en-US" smtClean="0"/>
+              <a:t>Click icon to add picture</a:t>
+            </a:r>
+            <a:endParaRPr lang="en-US" dirty="0"/>
+          </a:p>
+        </p:txBody>
+      </p:sp>
+      <p:sp>
+        <p:nvSpPr>
+          <p:cNvPr id="4" name="Text Placeholder 3"/>
+          <p:cNvSpPr>
+            <a:spLocks noGrp="1"/>
+          </p:cNvSpPr>
+          <p:nvPr>
+            <p:ph type="body" sz="half" idx="2"/>
+          </p:nvPr>
+        </p:nvSpPr>
+        <p:spPr>
+          <a:xfrm>
+            <a:off x="913795" y="5108728"/>
+            <a:ext cx="10365998" cy="682472"/>
+          </a:xfrm>
+        </p:spPr>
+        <p:txBody>
+          <a:bodyPr>
+            <a:normAutofit/>
+          </a:bodyPr>
+          <a:lstStyle>
+            <a:lvl1pPr marL="0" indent="0" algn="ctr">
+              <a:buNone/>
+              <a:defRPr sz="1800"/>
+            </a:lvl1pPr>
+            <a:lvl2pPr marL="457200" indent="0">
+              <a:buNone/>
+              <a:defRPr sz="1400"/>
+            </a:lvl2pPr>
+            <a:lvl3pPr marL="914400" indent="0">
+              <a:buNone/>
+              <a:defRPr sz="1200"/>
+            </a:lvl3pPr>
+            <a:lvl4pPr marL="1371600" indent="0">
+              <a:buNone/>
+              <a:defRPr sz="1000"/>
+            </a:lvl4pPr>
+            <a:lvl5pPr marL="1828800" indent="0">
+              <a:buNone/>
+              <a:defRPr sz="1000"/>
+            </a:lvl5pPr>
+            <a:lvl6pPr marL="2286000" indent="0">
+              <a:buNone/>
+              <a:defRPr sz="1000"/>
+            </a:lvl6pPr>
+            <a:lvl7pPr marL="2743200" indent="0">
+              <a:buNone/>
+              <a:defRPr sz="1000"/>
+            </a:lvl7pPr>
+            <a:lvl8pPr marL="3200400" indent="0">
+              <a:buNone/>
+              <a:defRPr sz="1000"/>
+            </a:lvl8pPr>
+            <a:lvl9pPr marL="3657600" indent="0">
+              <a:buNone/>
+              <a:defRPr sz="1000"/>
+            </a:lvl9pPr>
+          </a:lstStyle>
+          <a:p>
+            <a:pPr lvl="0"/>
+            <a:r>
+              <a:rPr lang="en-US" smtClean="0"/>
+              <a:t>Click to edit Master text styles</a:t>
+            </a:r>
+          </a:p>
+        </p:txBody>
+      </p:sp>
+      <p:sp>
+        <p:nvSpPr>
+          <p:cNvPr id="5" name="Date Placeholder 4"/>
+          <p:cNvSpPr>
+            <a:spLocks noGrp="1"/>
+          </p:cNvSpPr>
+          <p:nvPr>
+            <p:ph type="dt" sz="half" idx="10"/>
+          </p:nvPr>
+        </p:nvSpPr>
+        <p:spPr/>
+        <p:txBody>
+          <a:bodyPr/>
+          <a:lstStyle/>
+          <a:p>
+            <a:fld id="{5BCAD085-E8A6-8845-BD4E-CB4CCA059FC4}" type="datetimeFigureOut">
+              <a:rPr lang="en-US" smtClean="0"/>
+              <a:t>10/8/2026</a:t>
+            </a:fld>
+            <a:endParaRPr lang="en-US"/>
+          </a:p>
+        </p:txBody>
+      </p:sp>
+      <p:sp>
+        <p:nvSpPr>
+          <p:cNvPr id="6" name="Footer Placeholder 5"/>
+          <p:cNvSpPr>
+            <a:spLocks noGrp="1"/>
+          </p:cNvSpPr>
+          <p:nvPr>
+            <p:ph type="ftr" sz="quarter" idx="11"/>
+          </p:nvPr>
+        </p:nvSpPr>
+        <p:spPr/>
+        <p:txBody>
+          <a:bodyPr/>
+          <a:lstStyle/>
+          <a:p>
+            <a:endParaRPr lang="en-US"/>
+          </a:p>
+        </p:txBody>
+      </p:sp>
+      <p:sp>
+        <p:nvSpPr>
+          <p:cNvPr id="7" name="Slide Number Placeholder 6"/>
+          <p:cNvSpPr>
+            <a:spLocks noGrp="1"/>
+          </p:cNvSpPr>
+          <p:nvPr>
+            <p:ph type="sldNum" sz="quarter" idx="12"/>
+          </p:nvPr>
+        </p:nvSpPr>
+        <p:spPr/>
+        <p:txBody>
+          <a:bodyPr/>
+          <a:lstStyle/>
+          <a:p>
+            <a:fld id="{C1FF6DA9-008F-8B48-92A6-B652298478BF}" type="slidenum">
+              <a:rPr lang="en-US" smtClean="0"/>
+              <a:t>‹#›</a:t>
+            </a:fld>
+            <a:endParaRPr lang="en-US"/>
+          </a:p>
+        </p:txBody>
+      </p:sp>
+    </p:spTree>
+    <p:extLst>
+      <p:ext uri="{BB962C8B-B14F-4D97-AF65-F5344CB8AC3E}">
+        <p14:creationId xmlns:p14="http://schemas.microsoft.com/office/powerpoint/2010/main" val="275844455"/>
+      </p:ext>
+    </p:extLst>
+  </p:cSld>
+  <p:clrMapOvr>
+    <a:masterClrMapping/>
+  </p:clrMapOvr>
+</p:sldLayout>
+</file>
+
+<file path=ppt/slideLayouts/slideLayout11.xml><?xml version="1.0" encoding="utf-8"?>
+<p:sldLayout xmlns:a="http://schemas.openxmlformats.org/drawingml/2006/main" xmlns:r="http://schemas.openxmlformats.org/officeDocument/2006/relationships" xmlns:p="http://schemas.openxmlformats.org/presentationml/2006/main" preserve="1">
+  <p:cSld name="Title and Caption">
+    <p:spTree>
+      <p:nvGrpSpPr>
+        <p:cNvPr id="1" name=""/>
+        <p:cNvGrpSpPr/>
+        <p:nvPr/>
+      </p:nvGrpSpPr>
+      <p:grpSpPr>
+        <a:xfrm>
+          <a:off x="0" y="0"/>
+          <a:ext cx="0" cy="0"/>
+          <a:chOff x="0" y="0"/>
+          <a:chExt cx="0" cy="0"/>
+        </a:xfrm>
+      </p:grpSpPr>
+      <p:sp>
+        <p:nvSpPr>
+          <p:cNvPr id="2" name="Title 1"/>
+          <p:cNvSpPr>
+            <a:spLocks noGrp="1"/>
+          </p:cNvSpPr>
+          <p:nvPr>
+            <p:ph type="title"/>
+          </p:nvPr>
+        </p:nvSpPr>
+        <p:spPr>
+          <a:xfrm>
+            <a:off x="913795" y="609600"/>
+            <a:ext cx="10353762" cy="3424859"/>
+          </a:xfrm>
+        </p:spPr>
+        <p:txBody>
+          <a:bodyPr anchor="ctr"/>
+          <a:lstStyle>
+            <a:lvl1pPr>
+              <a:defRPr sz="3200"/>
+            </a:lvl1pPr>
+          </a:lstStyle>
+          <a:p>
+            <a:r>
+              <a:rPr lang="en-US" smtClean="0"/>
+              <a:t>Click to edit Master title style</a:t>
+            </a:r>
+            <a:endParaRPr lang="en-US" dirty="0"/>
+          </a:p>
+        </p:txBody>
+      </p:sp>
+      <p:sp>
+        <p:nvSpPr>
+          <p:cNvPr id="4" name="Text Placeholder 3"/>
+          <p:cNvSpPr>
+            <a:spLocks noGrp="1"/>
+          </p:cNvSpPr>
+          <p:nvPr>
+            <p:ph type="body" sz="half" idx="2"/>
+          </p:nvPr>
+        </p:nvSpPr>
+        <p:spPr>
+          <a:xfrm>
+            <a:off x="913795" y="4204820"/>
+            <a:ext cx="10353761" cy="1592186"/>
+          </a:xfrm>
+        </p:spPr>
+        <p:txBody>
+          <a:bodyPr anchor="ctr"/>
+          <a:lstStyle>
+            <a:lvl1pPr marL="0" indent="0" algn="ctr">
+              <a:buNone/>
+              <a:defRPr sz="1600"/>
+            </a:lvl1pPr>
+            <a:lvl2pPr marL="457200" indent="0">
+              <a:buNone/>
+              <a:defRPr sz="1400"/>
+            </a:lvl2pPr>
+            <a:lvl3pPr marL="914400" indent="0">
+              <a:buNone/>
+              <a:defRPr sz="1200"/>
+            </a:lvl3pPr>
+            <a:lvl4pPr marL="1371600" indent="0">
+              <a:buNone/>
+              <a:defRPr sz="1000"/>
+            </a:lvl4pPr>
+            <a:lvl5pPr marL="1828800" indent="0">
+              <a:buNone/>
+              <a:defRPr sz="1000"/>
+            </a:lvl5pPr>
+            <a:lvl6pPr marL="2286000" indent="0">
+              <a:buNone/>
+              <a:defRPr sz="1000"/>
+            </a:lvl6pPr>
+            <a:lvl7pPr marL="2743200" indent="0">
+              <a:buNone/>
+              <a:defRPr sz="1000"/>
+            </a:lvl7pPr>
+            <a:lvl8pPr marL="3200400" indent="0">
+              <a:buNone/>
+              <a:defRPr sz="1000"/>
+            </a:lvl8pPr>
+            <a:lvl9pPr marL="3657600" indent="0">
+              <a:buNone/>
+              <a:defRPr sz="1000"/>
+            </a:lvl9pPr>
+          </a:lstStyle>
+          <a:p>
+            <a:pPr lvl="0"/>
+            <a:r>
+              <a:rPr lang="en-US" smtClean="0"/>
+              <a:t>Click to edit Master text styles</a:t>
+            </a:r>
+          </a:p>
+        </p:txBody>
+      </p:sp>
+      <p:sp>
+        <p:nvSpPr>
+          <p:cNvPr id="5" name="Date Placeholder 4"/>
+          <p:cNvSpPr>
+            <a:spLocks noGrp="1"/>
+          </p:cNvSpPr>
+          <p:nvPr>
+            <p:ph type="dt" sz="half" idx="10"/>
+          </p:nvPr>
+        </p:nvSpPr>
+        <p:spPr/>
+        <p:txBody>
+          <a:bodyPr/>
+          <a:lstStyle/>
+          <a:p>
+            <a:fld id="{5BCAD085-E8A6-8845-BD4E-CB4CCA059FC4}" type="datetimeFigureOut">
+              <a:rPr lang="en-US" smtClean="0"/>
+              <a:t>10/8/2026</a:t>
+            </a:fld>
+            <a:endParaRPr lang="en-US"/>
+          </a:p>
+        </p:txBody>
+      </p:sp>
+      <p:sp>
+        <p:nvSpPr>
+          <p:cNvPr id="6" name="Footer Placeholder 5"/>
+          <p:cNvSpPr>
+            <a:spLocks noGrp="1"/>
+          </p:cNvSpPr>
+          <p:nvPr>
+            <p:ph type="ftr" sz="quarter" idx="11"/>
+          </p:nvPr>
+        </p:nvSpPr>
+        <p:spPr/>
+        <p:txBody>
+          <a:bodyPr/>
+          <a:lstStyle/>
+          <a:p>
+            <a:endParaRPr lang="en-US"/>
+          </a:p>
+        </p:txBody>
+      </p:sp>
+      <p:sp>
+        <p:nvSpPr>
+          <p:cNvPr id="7" name="Slide Number Placeholder 6"/>
+          <p:cNvSpPr>
+            <a:spLocks noGrp="1"/>
+          </p:cNvSpPr>
+          <p:nvPr>
+            <p:ph type="sldNum" sz="quarter" idx="12"/>
+          </p:nvPr>
+        </p:nvSpPr>
+        <p:spPr/>
+        <p:txBody>
+          <a:bodyPr/>
+          <a:lstStyle/>
+          <a:p>
+            <a:fld id="{C1FF6DA9-008F-8B48-92A6-B652298478BF}" type="slidenum">
+              <a:rPr lang="en-US" smtClean="0"/>
+              <a:t>‹#›</a:t>
+            </a:fld>
+            <a:endParaRPr lang="en-US"/>
+          </a:p>
+        </p:txBody>
+      </p:sp>
+    </p:spTree>
+    <p:extLst>
+      <p:ext uri="{BB962C8B-B14F-4D97-AF65-F5344CB8AC3E}">
+        <p14:creationId xmlns:p14="http://schemas.microsoft.com/office/powerpoint/2010/main" val="153379400"/>
+      </p:ext>
+    </p:extLst>
+  </p:cSld>
+  <p:clrMapOvr>
+    <a:masterClrMapping/>
+  </p:clrMapOvr>
+</p:sldLayout>
+</file>
+
+<file path=ppt/slideLayouts/slideLayout12.xml><?xml version="1.0" encoding="utf-8"?>
+<p:sldLayout xmlns:a="http://schemas.openxmlformats.org/drawingml/2006/main" xmlns:r="http://schemas.openxmlformats.org/officeDocument/2006/relationships" xmlns:p="http://schemas.openxmlformats.org/presentationml/2006/main" preserve="1">
+  <p:cSld name="Quote with Caption">
+    <p:spTree>
+      <p:nvGrpSpPr>
+        <p:cNvPr id="1" name=""/>
+        <p:cNvGrpSpPr/>
+        <p:nvPr/>
+      </p:nvGrpSpPr>
+      <p:grpSpPr>
+        <a:xfrm>
+          <a:off x="0" y="0"/>
+          <a:ext cx="0" cy="0"/>
+          <a:chOff x="0" y="0"/>
+          <a:chExt cx="0" cy="0"/>
+        </a:xfrm>
+      </p:grpSpPr>
+      <p:sp>
+        <p:nvSpPr>
+          <p:cNvPr id="2" name="Title 1"/>
+          <p:cNvSpPr>
+            <a:spLocks noGrp="1"/>
+          </p:cNvSpPr>
+          <p:nvPr>
+            <p:ph type="title"/>
+          </p:nvPr>
+        </p:nvSpPr>
+        <p:spPr>
+          <a:xfrm>
+            <a:off x="1446212" y="609600"/>
+            <a:ext cx="9302752" cy="2992904"/>
+          </a:xfrm>
+        </p:spPr>
+        <p:txBody>
+          <a:bodyPr anchor="ctr"/>
+          <a:lstStyle>
+            <a:lvl1pPr>
+              <a:defRPr sz="3200"/>
+            </a:lvl1pPr>
+          </a:lstStyle>
+          <a:p>
+            <a:r>
+              <a:rPr lang="en-US" smtClean="0"/>
+              <a:t>Click to edit Master title style</a:t>
+            </a:r>
+            <a:endParaRPr lang="en-US" dirty="0"/>
+          </a:p>
+        </p:txBody>
+      </p:sp>
+      <p:sp>
+        <p:nvSpPr>
+          <p:cNvPr id="12" name="Text Placeholder 3"/>
+          <p:cNvSpPr>
+            <a:spLocks noGrp="1"/>
+          </p:cNvSpPr>
+          <p:nvPr>
+            <p:ph type="body" sz="half" idx="13"/>
+          </p:nvPr>
+        </p:nvSpPr>
+        <p:spPr>
+          <a:xfrm>
+            <a:off x="1720644" y="3610032"/>
+            <a:ext cx="8752299" cy="426812"/>
+          </a:xfrm>
+        </p:spPr>
+        <p:txBody>
+          <a:bodyPr anchor="t">
+            <a:normAutofit/>
+          </a:bodyPr>
+          <a:lstStyle>
+            <a:lvl1pPr marL="0" indent="0" algn="r">
+              <a:buNone/>
+              <a:defRPr sz="1400"/>
+            </a:lvl1pPr>
+            <a:lvl2pPr marL="457200" indent="0">
+              <a:buNone/>
+              <a:defRPr sz="1400"/>
+            </a:lvl2pPr>
+            <a:lvl3pPr marL="914400" indent="0">
+              <a:buNone/>
+              <a:defRPr sz="1200"/>
+            </a:lvl3pPr>
+            <a:lvl4pPr marL="1371600" indent="0">
+              <a:buNone/>
+              <a:defRPr sz="1000"/>
+            </a:lvl4pPr>
+            <a:lvl5pPr marL="1828800" indent="0">
+              <a:buNone/>
+              <a:defRPr sz="1000"/>
+            </a:lvl5pPr>
+            <a:lvl6pPr marL="2286000" indent="0">
+              <a:buNone/>
+              <a:defRPr sz="1000"/>
+            </a:lvl6pPr>
+            <a:lvl7pPr marL="2743200" indent="0">
+              <a:buNone/>
+              <a:defRPr sz="1000"/>
+            </a:lvl7pPr>
+            <a:lvl8pPr marL="3200400" indent="0">
+              <a:buNone/>
+              <a:defRPr sz="1000"/>
+            </a:lvl8pPr>
+            <a:lvl9pPr marL="3657600" indent="0">
+              <a:buNone/>
+              <a:defRPr sz="1000"/>
+            </a:lvl9pPr>
+          </a:lstStyle>
+          <a:p>
+            <a:pPr lvl="0"/>
+            <a:r>
+              <a:rPr lang="en-US" smtClean="0"/>
+              <a:t>Click to edit Master text styles</a:t>
+            </a:r>
+          </a:p>
+        </p:txBody>
+      </p:sp>
+      <p:sp>
+        <p:nvSpPr>
+          <p:cNvPr id="4" name="Text Placeholder 3"/>
+          <p:cNvSpPr>
+            <a:spLocks noGrp="1"/>
+          </p:cNvSpPr>
+          <p:nvPr>
+            <p:ph type="body" sz="half" idx="2"/>
+          </p:nvPr>
+        </p:nvSpPr>
+        <p:spPr>
+          <a:xfrm>
+            <a:off x="913794" y="4204821"/>
+            <a:ext cx="10353762" cy="1586380"/>
+          </a:xfrm>
+        </p:spPr>
+        <p:txBody>
+          <a:bodyPr anchor="ctr">
+            <a:normAutofit/>
+          </a:bodyPr>
+          <a:lstStyle>
+            <a:lvl1pPr marL="0" indent="0" algn="ctr">
+              <a:buNone/>
+              <a:defRPr sz="1600"/>
+            </a:lvl1pPr>
+            <a:lvl2pPr marL="457200" indent="0">
+              <a:buNone/>
+              <a:defRPr sz="1400"/>
+            </a:lvl2pPr>
+            <a:lvl3pPr marL="914400" indent="0">
+              <a:buNone/>
+              <a:defRPr sz="1200"/>
+            </a:lvl3pPr>
+            <a:lvl4pPr marL="1371600" indent="0">
+              <a:buNone/>
+              <a:defRPr sz="1000"/>
+            </a:lvl4pPr>
+            <a:lvl5pPr marL="1828800" indent="0">
+              <a:buNone/>
+              <a:defRPr sz="1000"/>
+            </a:lvl5pPr>
+            <a:lvl6pPr marL="2286000" indent="0">
+              <a:buNone/>
+              <a:defRPr sz="1000"/>
+            </a:lvl6pPr>
+            <a:lvl7pPr marL="2743200" indent="0">
+              <a:buNone/>
+              <a:defRPr sz="1000"/>
+            </a:lvl7pPr>
+            <a:lvl8pPr marL="3200400" indent="0">
+              <a:buNone/>
+              <a:defRPr sz="1000"/>
+            </a:lvl8pPr>
+            <a:lvl9pPr marL="3657600" indent="0">
+              <a:buNone/>
+              <a:defRPr sz="1000"/>
+            </a:lvl9pPr>
+          </a:lstStyle>
+          <a:p>
+            <a:pPr lvl="0"/>
+            <a:r>
+              <a:rPr lang="en-US" smtClean="0"/>
+              <a:t>Click to edit Master text styles</a:t>
+            </a:r>
+          </a:p>
+        </p:txBody>
+      </p:sp>
+      <p:sp>
+        <p:nvSpPr>
+          <p:cNvPr id="5" name="Date Placeholder 4"/>
+          <p:cNvSpPr>
+            <a:spLocks noGrp="1"/>
+          </p:cNvSpPr>
+          <p:nvPr>
+            <p:ph type="dt" sz="half" idx="10"/>
+          </p:nvPr>
+        </p:nvSpPr>
+        <p:spPr/>
+        <p:txBody>
+          <a:bodyPr/>
+          <a:lstStyle/>
+          <a:p>
+            <a:fld id="{5BCAD085-E8A6-8845-BD4E-CB4CCA059FC4}" type="datetimeFigureOut">
+              <a:rPr lang="en-US" smtClean="0"/>
+              <a:t>10/8/2026</a:t>
+            </a:fld>
+            <a:endParaRPr lang="en-US"/>
+          </a:p>
+        </p:txBody>
+      </p:sp>
+      <p:sp>
+        <p:nvSpPr>
+          <p:cNvPr id="6" name="Footer Placeholder 5"/>
+          <p:cNvSpPr>
+            <a:spLocks noGrp="1"/>
+          </p:cNvSpPr>
+          <p:nvPr>
+            <p:ph type="ftr" sz="quarter" idx="11"/>
+          </p:nvPr>
+        </p:nvSpPr>
+        <p:spPr/>
+        <p:txBody>
+          <a:bodyPr/>
+          <a:lstStyle/>
+          <a:p>
+            <a:endParaRPr lang="en-US"/>
+          </a:p>
+        </p:txBody>
+      </p:sp>
+      <p:sp>
+        <p:nvSpPr>
+          <p:cNvPr id="7" name="Slide Number Placeholder 6"/>
+          <p:cNvSpPr>
+            <a:spLocks noGrp="1"/>
+          </p:cNvSpPr>
+          <p:nvPr>
+            <p:ph type="sldNum" sz="quarter" idx="12"/>
+          </p:nvPr>
+        </p:nvSpPr>
+        <p:spPr/>
+        <p:txBody>
+          <a:bodyPr/>
+          <a:lstStyle/>
+          <a:p>
+            <a:fld id="{C1FF6DA9-008F-8B48-92A6-B652298478BF}" type="slidenum">
+              <a:rPr lang="en-US" smtClean="0"/>
+              <a:t>‹#›</a:t>
+            </a:fld>
+            <a:endParaRPr lang="en-US"/>
+          </a:p>
+        </p:txBody>
+      </p:sp>
+      <p:sp>
+        <p:nvSpPr>
+          <p:cNvPr id="11" name="TextBox 10"/>
+          <p:cNvSpPr txBox="1"/>
+          <p:nvPr/>
+        </p:nvSpPr>
+        <p:spPr>
+          <a:xfrm>
+            <a:off x="836612" y="735241"/>
+            <a:ext cx="609600" cy="584776"/>
+          </a:xfrm>
+          <a:prstGeom prst="rect">
+            <a:avLst/>
+          </a:prstGeom>
+        </p:spPr>
+        <p:txBody>
+          <a:bodyPr vert="horz" lIns="91440" tIns="45720" rIns="91440" bIns="45720" rtlCol="0" anchor="ctr">
+            <a:noAutofit/>
+          </a:bodyPr>
+          <a:lstStyle>
+            <a:lvl1pPr>
+              <a:spcBef>
+                <a:spcPct val="0"/>
+              </a:spcBef>
+              <a:buNone/>
+              <a:defRPr sz="3200" b="0" cap="all">
+                <a:ln w="3175" cmpd="sng">
+                  <a:noFill/>
+                </a:ln>
+                <a:effectLst>
+                  <a:glow rad="38100">
+                    <a:schemeClr val="bg1">
+                      <a:lumMod val="65000"/>
+                      <a:lumOff val="35000"/>
+                      <a:alpha val="40000"/>
+                    </a:schemeClr>
+                  </a:glow>
+                  <a:outerShdw blurRad="28575" dist="38100" dir="14040000" algn="tl" rotWithShape="0">
+                    <a:srgbClr val="000000">
+                      <a:alpha val="25000"/>
+                    </a:srgbClr>
+                  </a:outerShdw>
+                </a:effectLst>
+              </a:defRPr>
+            </a:lvl1pPr>
+            <a:lvl2pPr>
+              <a:defRPr>
+                <a:solidFill>
+                  <a:schemeClr val="tx2"/>
+                </a:solidFill>
+              </a:defRPr>
+            </a:lvl2pPr>
+            <a:lvl3pPr>
+              <a:defRPr>
+                <a:solidFill>
+                  <a:schemeClr val="tx2"/>
+                </a:solidFill>
+              </a:defRPr>
+            </a:lvl3pPr>
+            <a:lvl4pPr>
+              <a:defRPr>
+                <a:solidFill>
+                  <a:schemeClr val="tx2"/>
+                </a:solidFill>
+              </a:defRPr>
+            </a:lvl4pPr>
+            <a:lvl5pPr>
+              <a:defRPr>
+                <a:solidFill>
+                  <a:schemeClr val="tx2"/>
+                </a:solidFill>
+              </a:defRPr>
+            </a:lvl5pPr>
+            <a:lvl6pPr>
+              <a:defRPr>
+                <a:solidFill>
+                  <a:schemeClr val="tx2"/>
+                </a:solidFill>
+              </a:defRPr>
+            </a:lvl6pPr>
+            <a:lvl7pPr>
+              <a:defRPr>
+                <a:solidFill>
+                  <a:schemeClr val="tx2"/>
+                </a:solidFill>
+              </a:defRPr>
+            </a:lvl7pPr>
+            <a:lvl8pPr>
+              <a:defRPr>
+                <a:solidFill>
+                  <a:schemeClr val="tx2"/>
+                </a:solidFill>
+              </a:defRPr>
+            </a:lvl8pPr>
+            <a:lvl9pPr>
+              <a:defRPr>
+                <a:solidFill>
+                  <a:schemeClr val="tx2"/>
+                </a:solidFill>
+              </a:defRPr>
+            </a:lvl9pPr>
+          </a:lstStyle>
+          <a:p>
+            <a:pPr lvl="0"/>
+            <a:r>
+              <a:rPr lang="en-US" sz="8000" dirty="0">
+                <a:solidFill>
+                  <a:schemeClr val="tx1"/>
+                </a:solidFill>
+                <a:effectLst/>
+              </a:rPr>
+              <a:t>“</a:t>
+            </a:r>
+          </a:p>
+        </p:txBody>
+      </p:sp>
+      <p:sp>
+        <p:nvSpPr>
+          <p:cNvPr id="13" name="TextBox 12"/>
+          <p:cNvSpPr txBox="1"/>
+          <p:nvPr/>
+        </p:nvSpPr>
+        <p:spPr>
+          <a:xfrm>
+            <a:off x="10657956" y="2972093"/>
+            <a:ext cx="609600" cy="584776"/>
+          </a:xfrm>
+          <a:prstGeom prst="rect">
+            <a:avLst/>
+          </a:prstGeom>
+        </p:spPr>
+        <p:txBody>
+          <a:bodyPr vert="horz" lIns="91440" tIns="45720" rIns="91440" bIns="45720" rtlCol="0" anchor="ctr">
+            <a:noAutofit/>
+          </a:bodyPr>
+          <a:lstStyle>
+            <a:lvl1pPr>
+              <a:spcBef>
+                <a:spcPct val="0"/>
+              </a:spcBef>
+              <a:buNone/>
+              <a:defRPr sz="3200" b="0" cap="all">
+                <a:ln w="3175" cmpd="sng">
+                  <a:noFill/>
+                </a:ln>
+                <a:effectLst>
+                  <a:glow rad="38100">
+                    <a:schemeClr val="bg1">
+                      <a:lumMod val="65000"/>
+                      <a:lumOff val="35000"/>
+                      <a:alpha val="40000"/>
+                    </a:schemeClr>
+                  </a:glow>
+                  <a:outerShdw blurRad="28575" dist="38100" dir="14040000" algn="tl" rotWithShape="0">
+                    <a:srgbClr val="000000">
+                      <a:alpha val="25000"/>
+                    </a:srgbClr>
+                  </a:outerShdw>
+                </a:effectLst>
+              </a:defRPr>
+            </a:lvl1pPr>
+            <a:lvl2pPr>
+              <a:defRPr>
+                <a:solidFill>
+                  <a:schemeClr val="tx2"/>
+                </a:solidFill>
+              </a:defRPr>
+            </a:lvl2pPr>
+            <a:lvl3pPr>
+              <a:defRPr>
+                <a:solidFill>
+                  <a:schemeClr val="tx2"/>
+                </a:solidFill>
+              </a:defRPr>
+            </a:lvl3pPr>
+            <a:lvl4pPr>
+              <a:defRPr>
+                <a:solidFill>
+                  <a:schemeClr val="tx2"/>
+                </a:solidFill>
+              </a:defRPr>
+            </a:lvl4pPr>
+            <a:lvl5pPr>
+              <a:defRPr>
+                <a:solidFill>
+                  <a:schemeClr val="tx2"/>
+                </a:solidFill>
+              </a:defRPr>
+            </a:lvl5pPr>
+            <a:lvl6pPr>
+              <a:defRPr>
+                <a:solidFill>
+                  <a:schemeClr val="tx2"/>
+                </a:solidFill>
+              </a:defRPr>
+            </a:lvl6pPr>
+            <a:lvl7pPr>
+              <a:defRPr>
+                <a:solidFill>
+                  <a:schemeClr val="tx2"/>
+                </a:solidFill>
+              </a:defRPr>
+            </a:lvl7pPr>
+            <a:lvl8pPr>
+              <a:defRPr>
+                <a:solidFill>
+                  <a:schemeClr val="tx2"/>
+                </a:solidFill>
+              </a:defRPr>
+            </a:lvl8pPr>
+            <a:lvl9pPr>
+              <a:defRPr>
+                <a:solidFill>
+                  <a:schemeClr val="tx2"/>
+                </a:solidFill>
+              </a:defRPr>
+            </a:lvl9pPr>
+          </a:lstStyle>
+          <a:p>
+            <a:pPr lvl="0" algn="r"/>
+            <a:r>
+              <a:rPr lang="en-US" sz="8000" dirty="0">
+                <a:solidFill>
+                  <a:schemeClr val="tx1"/>
+                </a:solidFill>
+                <a:effectLst/>
+              </a:rPr>
+              <a:t>”</a:t>
+            </a:r>
+          </a:p>
+        </p:txBody>
+      </p:sp>
+    </p:spTree>
+    <p:extLst>
+      <p:ext uri="{BB962C8B-B14F-4D97-AF65-F5344CB8AC3E}">
+        <p14:creationId xmlns:p14="http://schemas.microsoft.com/office/powerpoint/2010/main" val="438872526"/>
+      </p:ext>
+    </p:extLst>
+  </p:cSld>
+  <p:clrMapOvr>
+    <a:masterClrMapping/>
+  </p:clrMapOvr>
+</p:sldLayout>
+</file>
+
+<file path=ppt/slideLayouts/slideLayout13.xml><?xml version="1.0" encoding="utf-8"?>
+<p:sldLayout xmlns:a="http://schemas.openxmlformats.org/drawingml/2006/main" xmlns:r="http://schemas.openxmlformats.org/officeDocument/2006/relationships" xmlns:p="http://schemas.openxmlformats.org/presentationml/2006/main" preserve="1">
+  <p:cSld name="Name Card">
+    <p:spTree>
+      <p:nvGrpSpPr>
+        <p:cNvPr id="1" name=""/>
+        <p:cNvGrpSpPr/>
+        <p:nvPr/>
+      </p:nvGrpSpPr>
+      <p:grpSpPr>
+        <a:xfrm>
+          <a:off x="0" y="0"/>
+          <a:ext cx="0" cy="0"/>
+          <a:chOff x="0" y="0"/>
+          <a:chExt cx="0" cy="0"/>
+        </a:xfrm>
+      </p:grpSpPr>
+      <p:sp>
+        <p:nvSpPr>
+          <p:cNvPr id="2" name="Title 1"/>
+          <p:cNvSpPr>
+            <a:spLocks noGrp="1"/>
+          </p:cNvSpPr>
+          <p:nvPr>
+            <p:ph type="title"/>
+          </p:nvPr>
+        </p:nvSpPr>
+        <p:spPr>
+          <a:xfrm>
+            <a:off x="913806" y="2126942"/>
+            <a:ext cx="10355327" cy="2511835"/>
+          </a:xfrm>
+        </p:spPr>
+        <p:txBody>
+          <a:bodyPr anchor="b"/>
+          <a:lstStyle>
+            <a:lvl1pPr>
+              <a:defRPr sz="3200"/>
+            </a:lvl1pPr>
+          </a:lstStyle>
+          <a:p>
+            <a:r>
+              <a:rPr lang="en-US" smtClean="0"/>
+              <a:t>Click to edit Master title style</a:t>
+            </a:r>
+            <a:endParaRPr lang="en-US" dirty="0"/>
+          </a:p>
+        </p:txBody>
+      </p:sp>
+      <p:sp>
+        <p:nvSpPr>
+          <p:cNvPr id="4" name="Text Placeholder 3"/>
+          <p:cNvSpPr>
+            <a:spLocks noGrp="1"/>
+          </p:cNvSpPr>
+          <p:nvPr>
+            <p:ph type="body" sz="half" idx="2"/>
+          </p:nvPr>
+        </p:nvSpPr>
+        <p:spPr>
+          <a:xfrm>
+            <a:off x="913794" y="4650556"/>
+            <a:ext cx="10353763" cy="1140644"/>
+          </a:xfrm>
+        </p:spPr>
+        <p:txBody>
+          <a:bodyPr anchor="t"/>
+          <a:lstStyle>
+            <a:lvl1pPr marL="0" indent="0" algn="ctr">
+              <a:buNone/>
+              <a:defRPr sz="1600"/>
+            </a:lvl1pPr>
+            <a:lvl2pPr marL="457200" indent="0">
+              <a:buNone/>
+              <a:defRPr sz="1400"/>
+            </a:lvl2pPr>
+            <a:lvl3pPr marL="914400" indent="0">
+              <a:buNone/>
+              <a:defRPr sz="1200"/>
+            </a:lvl3pPr>
+            <a:lvl4pPr marL="1371600" indent="0">
+              <a:buNone/>
+              <a:defRPr sz="1000"/>
+            </a:lvl4pPr>
+            <a:lvl5pPr marL="1828800" indent="0">
+              <a:buNone/>
+              <a:defRPr sz="1000"/>
+            </a:lvl5pPr>
+            <a:lvl6pPr marL="2286000" indent="0">
+              <a:buNone/>
+              <a:defRPr sz="1000"/>
+            </a:lvl6pPr>
+            <a:lvl7pPr marL="2743200" indent="0">
+              <a:buNone/>
+              <a:defRPr sz="1000"/>
+            </a:lvl7pPr>
+            <a:lvl8pPr marL="3200400" indent="0">
+              <a:buNone/>
+              <a:defRPr sz="1000"/>
+            </a:lvl8pPr>
+            <a:lvl9pPr marL="3657600" indent="0">
+              <a:buNone/>
+              <a:defRPr sz="1000"/>
+            </a:lvl9pPr>
+          </a:lstStyle>
+          <a:p>
+            <a:pPr lvl="0"/>
+            <a:r>
+              <a:rPr lang="en-US" smtClean="0"/>
+              <a:t>Click to edit Master text styles</a:t>
+            </a:r>
+          </a:p>
+        </p:txBody>
+      </p:sp>
+      <p:sp>
+        <p:nvSpPr>
+          <p:cNvPr id="5" name="Date Placeholder 4"/>
+          <p:cNvSpPr>
+            <a:spLocks noGrp="1"/>
+          </p:cNvSpPr>
+          <p:nvPr>
+            <p:ph type="dt" sz="half" idx="10"/>
+          </p:nvPr>
+        </p:nvSpPr>
+        <p:spPr/>
+        <p:txBody>
+          <a:bodyPr/>
+          <a:lstStyle/>
+          <a:p>
+            <a:fld id="{5BCAD085-E8A6-8845-BD4E-CB4CCA059FC4}" type="datetimeFigureOut">
+              <a:rPr lang="en-US" smtClean="0"/>
+              <a:t>10/8/2026</a:t>
+            </a:fld>
+            <a:endParaRPr lang="en-US"/>
+          </a:p>
+        </p:txBody>
+      </p:sp>
+      <p:sp>
+        <p:nvSpPr>
+          <p:cNvPr id="6" name="Footer Placeholder 5"/>
+          <p:cNvSpPr>
+            <a:spLocks noGrp="1"/>
+          </p:cNvSpPr>
+          <p:nvPr>
+            <p:ph type="ftr" sz="quarter" idx="11"/>
+          </p:nvPr>
+        </p:nvSpPr>
+        <p:spPr/>
+        <p:txBody>
+          <a:bodyPr/>
+          <a:lstStyle/>
+          <a:p>
+            <a:endParaRPr lang="en-US"/>
+          </a:p>
+        </p:txBody>
+      </p:sp>
+      <p:sp>
+        <p:nvSpPr>
+          <p:cNvPr id="7" name="Slide Number Placeholder 6"/>
+          <p:cNvSpPr>
+            <a:spLocks noGrp="1"/>
+          </p:cNvSpPr>
+          <p:nvPr>
+            <p:ph type="sldNum" sz="quarter" idx="12"/>
+          </p:nvPr>
+        </p:nvSpPr>
+        <p:spPr/>
+        <p:txBody>
+          <a:bodyPr/>
+          <a:lstStyle/>
+          <a:p>
+            <a:fld id="{C1FF6DA9-008F-8B48-92A6-B652298478BF}" type="slidenum">
+              <a:rPr lang="en-US" smtClean="0"/>
+              <a:t>‹#›</a:t>
+            </a:fld>
+            <a:endParaRPr lang="en-US"/>
+          </a:p>
+        </p:txBody>
+      </p:sp>
+    </p:spTree>
+    <p:extLst>
+      <p:ext uri="{BB962C8B-B14F-4D97-AF65-F5344CB8AC3E}">
+        <p14:creationId xmlns:p14="http://schemas.microsoft.com/office/powerpoint/2010/main" val="644797971"/>
+      </p:ext>
+    </p:extLst>
+  </p:cSld>
+  <p:clrMapOvr>
+    <a:masterClrMapping/>
+  </p:clrMapOvr>
+</p:sldLayout>
+</file>
+
+<file path=ppt/slideLayouts/slideLayout14.xml><?xml version="1.0" encoding="utf-8"?>
+<p:sldLayout xmlns:a="http://schemas.openxmlformats.org/drawingml/2006/main" xmlns:r="http://schemas.openxmlformats.org/officeDocument/2006/relationships" xmlns:p="http://schemas.openxmlformats.org/presentationml/2006/main" preserve="1">
+  <p:cSld name="3 Column">
+    <p:spTree>
+      <p:nvGrpSpPr>
+        <p:cNvPr id="1" name=""/>
+        <p:cNvGrpSpPr/>
+        <p:nvPr/>
+      </p:nvGrpSpPr>
+      <p:grpSpPr>
+        <a:xfrm>
+          <a:off x="0" y="0"/>
+          <a:ext cx="0" cy="0"/>
+          <a:chOff x="0" y="0"/>
+          <a:chExt cx="0" cy="0"/>
+        </a:xfrm>
+      </p:grpSpPr>
+      <p:sp>
+        <p:nvSpPr>
+          <p:cNvPr id="15" name="Title 1"/>
+          <p:cNvSpPr>
+            <a:spLocks noGrp="1"/>
+          </p:cNvSpPr>
+          <p:nvPr>
+            <p:ph type="title"/>
+          </p:nvPr>
+        </p:nvSpPr>
+        <p:spPr>
+          <a:xfrm>
+            <a:off x="913794" y="609600"/>
+            <a:ext cx="10353762" cy="1325563"/>
+          </a:xfrm>
+        </p:spPr>
+        <p:txBody>
+          <a:bodyPr/>
+          <a:lstStyle/>
+          <a:p>
+            <a:r>
+              <a:rPr lang="en-US" smtClean="0"/>
+              <a:t>Click to edit Master title style</a:t>
+            </a:r>
+            <a:endParaRPr lang="en-US" dirty="0"/>
+          </a:p>
+        </p:txBody>
+      </p:sp>
+      <p:sp>
+        <p:nvSpPr>
+          <p:cNvPr id="7" name="Text Placeholder 2"/>
+          <p:cNvSpPr>
+            <a:spLocks noGrp="1"/>
+          </p:cNvSpPr>
+          <p:nvPr>
+            <p:ph type="body" idx="1"/>
+          </p:nvPr>
+        </p:nvSpPr>
+        <p:spPr>
+          <a:xfrm>
+            <a:off x="913794" y="2088319"/>
+            <a:ext cx="3298956" cy="823305"/>
+          </a:xfrm>
+        </p:spPr>
+        <p:txBody>
+          <a:bodyPr anchor="b">
+            <a:noAutofit/>
+          </a:bodyPr>
+          <a:lstStyle>
+            <a:lvl1pPr marL="0" indent="0" algn="ctr">
+              <a:lnSpc>
+                <a:spcPct val="100000"/>
+              </a:lnSpc>
+              <a:buNone/>
+              <a:defRPr sz="2400" b="0">
+                <a:solidFill>
+                  <a:schemeClr val="tx1"/>
+                </a:solidFill>
+              </a:defRPr>
+            </a:lvl1pPr>
+            <a:lvl2pPr marL="457200" indent="0">
+              <a:buNone/>
+              <a:defRPr sz="2000" b="1"/>
+            </a:lvl2pPr>
+            <a:lvl3pPr marL="914400" indent="0">
+              <a:buNone/>
+              <a:defRPr sz="1800" b="1"/>
+            </a:lvl3pPr>
+            <a:lvl4pPr marL="1371600" indent="0">
+              <a:buNone/>
+              <a:defRPr sz="1600" b="1"/>
+            </a:lvl4pPr>
+            <a:lvl5pPr marL="1828800" indent="0">
+              <a:buNone/>
+              <a:defRPr sz="1600" b="1"/>
+            </a:lvl5pPr>
+            <a:lvl6pPr marL="2286000" indent="0">
+              <a:buNone/>
+              <a:defRPr sz="1600" b="1"/>
+            </a:lvl6pPr>
+            <a:lvl7pPr marL="2743200" indent="0">
+              <a:buNone/>
+              <a:defRPr sz="1600" b="1"/>
+            </a:lvl7pPr>
+            <a:lvl8pPr marL="3200400" indent="0">
+              <a:buNone/>
+              <a:defRPr sz="1600" b="1"/>
+            </a:lvl8pPr>
+            <a:lvl9pPr marL="3657600" indent="0">
+              <a:buNone/>
+              <a:defRPr sz="1600" b="1"/>
+            </a:lvl9pPr>
+          </a:lstStyle>
+          <a:p>
+            <a:pPr lvl="0"/>
+            <a:r>
+              <a:rPr lang="en-US" smtClean="0"/>
+              <a:t>Click to edit Master text styles</a:t>
+            </a:r>
+          </a:p>
+        </p:txBody>
+      </p:sp>
+      <p:sp>
+        <p:nvSpPr>
+          <p:cNvPr id="8" name="Text Placeholder 3"/>
+          <p:cNvSpPr>
+            <a:spLocks noGrp="1"/>
+          </p:cNvSpPr>
+          <p:nvPr>
+            <p:ph type="body" sz="half" idx="15"/>
+          </p:nvPr>
+        </p:nvSpPr>
+        <p:spPr>
+          <a:xfrm>
+            <a:off x="913794" y="2911624"/>
+            <a:ext cx="3298956" cy="2879576"/>
+          </a:xfrm>
+        </p:spPr>
+        <p:txBody>
+          <a:bodyPr anchor="t">
+            <a:normAutofit/>
+          </a:bodyPr>
+          <a:lstStyle>
+            <a:lvl1pPr marL="0" indent="0" algn="ctr">
+              <a:buNone/>
+              <a:defRPr sz="1400"/>
+            </a:lvl1pPr>
+            <a:lvl2pPr marL="457200" indent="0">
+              <a:buNone/>
+              <a:defRPr sz="1200"/>
+            </a:lvl2pPr>
+            <a:lvl3pPr marL="914400" indent="0">
+              <a:buNone/>
+              <a:defRPr sz="1000"/>
+            </a:lvl3pPr>
+            <a:lvl4pPr marL="1371600" indent="0">
+              <a:buNone/>
+              <a:defRPr sz="900"/>
+            </a:lvl4pPr>
+            <a:lvl5pPr marL="1828800" indent="0">
+              <a:buNone/>
+              <a:defRPr sz="900"/>
+            </a:lvl5pPr>
+            <a:lvl6pPr marL="2286000" indent="0">
+              <a:buNone/>
+              <a:defRPr sz="900"/>
+            </a:lvl6pPr>
+            <a:lvl7pPr marL="2743200" indent="0">
+              <a:buNone/>
+              <a:defRPr sz="900"/>
+            </a:lvl7pPr>
+            <a:lvl8pPr marL="3200400" indent="0">
+              <a:buNone/>
+              <a:defRPr sz="900"/>
+            </a:lvl8pPr>
+            <a:lvl9pPr marL="3657600" indent="0">
+              <a:buNone/>
+              <a:defRPr sz="900"/>
+            </a:lvl9pPr>
+          </a:lstStyle>
+          <a:p>
+            <a:pPr lvl="0"/>
+            <a:r>
+              <a:rPr lang="en-US" smtClean="0"/>
+              <a:t>Click to edit Master text styles</a:t>
+            </a:r>
+          </a:p>
+        </p:txBody>
+      </p:sp>
+      <p:sp>
+        <p:nvSpPr>
+          <p:cNvPr id="9" name="Text Placeholder 4"/>
+          <p:cNvSpPr>
+            <a:spLocks noGrp="1"/>
+          </p:cNvSpPr>
+          <p:nvPr>
+            <p:ph type="body" sz="quarter" idx="3"/>
+          </p:nvPr>
+        </p:nvSpPr>
+        <p:spPr>
+          <a:xfrm>
+            <a:off x="4444878" y="2088320"/>
+            <a:ext cx="3298558" cy="823304"/>
+          </a:xfrm>
+        </p:spPr>
+        <p:txBody>
+          <a:bodyPr anchor="b">
+            <a:noAutofit/>
+          </a:bodyPr>
+          <a:lstStyle>
+            <a:lvl1pPr marL="0" indent="0" algn="ctr">
+              <a:lnSpc>
+                <a:spcPct val="100000"/>
+              </a:lnSpc>
+              <a:buNone/>
+              <a:defRPr sz="2400" b="0">
+                <a:solidFill>
+                  <a:schemeClr val="tx1"/>
+                </a:solidFill>
+              </a:defRPr>
+            </a:lvl1pPr>
+            <a:lvl2pPr marL="457200" indent="0">
+              <a:buNone/>
+              <a:defRPr sz="2000" b="1"/>
+            </a:lvl2pPr>
+            <a:lvl3pPr marL="914400" indent="0">
+              <a:buNone/>
+              <a:defRPr sz="1800" b="1"/>
+            </a:lvl3pPr>
+            <a:lvl4pPr marL="1371600" indent="0">
+              <a:buNone/>
+              <a:defRPr sz="1600" b="1"/>
+            </a:lvl4pPr>
+            <a:lvl5pPr marL="1828800" indent="0">
+              <a:buNone/>
+              <a:defRPr sz="1600" b="1"/>
+            </a:lvl5pPr>
+            <a:lvl6pPr marL="2286000" indent="0">
+              <a:buNone/>
+              <a:defRPr sz="1600" b="1"/>
+            </a:lvl6pPr>
+            <a:lvl7pPr marL="2743200" indent="0">
+              <a:buNone/>
+              <a:defRPr sz="1600" b="1"/>
+            </a:lvl7pPr>
+            <a:lvl8pPr marL="3200400" indent="0">
+              <a:buNone/>
+              <a:defRPr sz="1600" b="1"/>
+            </a:lvl8pPr>
+            <a:lvl9pPr marL="3657600" indent="0">
+              <a:buNone/>
+              <a:defRPr sz="1600" b="1"/>
+            </a:lvl9pPr>
+          </a:lstStyle>
+          <a:p>
+            <a:pPr lvl="0"/>
+            <a:r>
+              <a:rPr lang="en-US" smtClean="0"/>
+              <a:t>Click to edit Master text styles</a:t>
+            </a:r>
+          </a:p>
+        </p:txBody>
+      </p:sp>
+      <p:sp>
+        <p:nvSpPr>
+          <p:cNvPr id="10" name="Text Placeholder 3"/>
+          <p:cNvSpPr>
+            <a:spLocks noGrp="1"/>
+          </p:cNvSpPr>
+          <p:nvPr>
+            <p:ph type="body" sz="half" idx="16"/>
+          </p:nvPr>
+        </p:nvSpPr>
+        <p:spPr>
+          <a:xfrm>
+            <a:off x="4444878" y="2911624"/>
+            <a:ext cx="3299821" cy="2879576"/>
+          </a:xfrm>
+        </p:spPr>
+        <p:txBody>
+          <a:bodyPr anchor="t">
+            <a:normAutofit/>
+          </a:bodyPr>
+          <a:lstStyle>
+            <a:lvl1pPr marL="0" indent="0" algn="ctr">
+              <a:buNone/>
+              <a:defRPr sz="1400"/>
+            </a:lvl1pPr>
+            <a:lvl2pPr marL="457200" indent="0">
+              <a:buNone/>
+              <a:defRPr sz="1200"/>
+            </a:lvl2pPr>
+            <a:lvl3pPr marL="914400" indent="0">
+              <a:buNone/>
+              <a:defRPr sz="1000"/>
+            </a:lvl3pPr>
+            <a:lvl4pPr marL="1371600" indent="0">
+              <a:buNone/>
+              <a:defRPr sz="900"/>
+            </a:lvl4pPr>
+            <a:lvl5pPr marL="1828800" indent="0">
+              <a:buNone/>
+              <a:defRPr sz="900"/>
+            </a:lvl5pPr>
+            <a:lvl6pPr marL="2286000" indent="0">
+              <a:buNone/>
+              <a:defRPr sz="900"/>
+            </a:lvl6pPr>
+            <a:lvl7pPr marL="2743200" indent="0">
+              <a:buNone/>
+              <a:defRPr sz="900"/>
+            </a:lvl7pPr>
+            <a:lvl8pPr marL="3200400" indent="0">
+              <a:buNone/>
+              <a:defRPr sz="900"/>
+            </a:lvl8pPr>
+            <a:lvl9pPr marL="3657600" indent="0">
+              <a:buNone/>
+              <a:defRPr sz="900"/>
+            </a:lvl9pPr>
+          </a:lstStyle>
+          <a:p>
+            <a:pPr lvl="0"/>
+            <a:r>
+              <a:rPr lang="en-US" smtClean="0"/>
+              <a:t>Click to edit Master text styles</a:t>
+            </a:r>
+          </a:p>
+        </p:txBody>
+      </p:sp>
+      <p:sp>
+        <p:nvSpPr>
+          <p:cNvPr id="11" name="Text Placeholder 4"/>
+          <p:cNvSpPr>
+            <a:spLocks noGrp="1"/>
+          </p:cNvSpPr>
+          <p:nvPr>
+            <p:ph type="body" sz="quarter" idx="13"/>
+          </p:nvPr>
+        </p:nvSpPr>
+        <p:spPr>
+          <a:xfrm>
+            <a:off x="7973298" y="2088320"/>
+            <a:ext cx="3291211" cy="823304"/>
+          </a:xfrm>
+        </p:spPr>
+        <p:txBody>
+          <a:bodyPr anchor="b">
+            <a:noAutofit/>
+          </a:bodyPr>
+          <a:lstStyle>
+            <a:lvl1pPr marL="0" indent="0" algn="ctr">
+              <a:lnSpc>
+                <a:spcPct val="100000"/>
+              </a:lnSpc>
+              <a:buNone/>
+              <a:defRPr sz="2400" b="0">
+                <a:solidFill>
+                  <a:schemeClr val="tx1"/>
+                </a:solidFill>
+              </a:defRPr>
+            </a:lvl1pPr>
+            <a:lvl2pPr marL="457200" indent="0">
+              <a:buNone/>
+              <a:defRPr sz="2000" b="1"/>
+            </a:lvl2pPr>
+            <a:lvl3pPr marL="914400" indent="0">
+              <a:buNone/>
+              <a:defRPr sz="1800" b="1"/>
+            </a:lvl3pPr>
+            <a:lvl4pPr marL="1371600" indent="0">
+              <a:buNone/>
+              <a:defRPr sz="1600" b="1"/>
+            </a:lvl4pPr>
+            <a:lvl5pPr marL="1828800" indent="0">
+              <a:buNone/>
+              <a:defRPr sz="1600" b="1"/>
+            </a:lvl5pPr>
+            <a:lvl6pPr marL="2286000" indent="0">
+              <a:buNone/>
+              <a:defRPr sz="1600" b="1"/>
+            </a:lvl6pPr>
+            <a:lvl7pPr marL="2743200" indent="0">
+              <a:buNone/>
+              <a:defRPr sz="1600" b="1"/>
+            </a:lvl7pPr>
+            <a:lvl8pPr marL="3200400" indent="0">
+              <a:buNone/>
+              <a:defRPr sz="1600" b="1"/>
+            </a:lvl8pPr>
+            <a:lvl9pPr marL="3657600" indent="0">
+              <a:buNone/>
+              <a:defRPr sz="1600" b="1"/>
+            </a:lvl9pPr>
+          </a:lstStyle>
+          <a:p>
+            <a:pPr lvl="0"/>
+            <a:r>
+              <a:rPr lang="en-US" smtClean="0"/>
+              <a:t>Click to edit Master text styles</a:t>
+            </a:r>
+          </a:p>
+        </p:txBody>
+      </p:sp>
+      <p:sp>
+        <p:nvSpPr>
+          <p:cNvPr id="12" name="Text Placeholder 3"/>
+          <p:cNvSpPr>
+            <a:spLocks noGrp="1"/>
+          </p:cNvSpPr>
+          <p:nvPr>
+            <p:ph type="body" sz="half" idx="17"/>
+          </p:nvPr>
+        </p:nvSpPr>
+        <p:spPr>
+          <a:xfrm>
+            <a:off x="7976346" y="2911624"/>
+            <a:ext cx="3291211" cy="2879576"/>
+          </a:xfrm>
+        </p:spPr>
+        <p:txBody>
+          <a:bodyPr anchor="t">
+            <a:normAutofit/>
+          </a:bodyPr>
+          <a:lstStyle>
+            <a:lvl1pPr marL="0" indent="0" algn="ctr">
+              <a:buNone/>
+              <a:defRPr sz="1400"/>
+            </a:lvl1pPr>
+            <a:lvl2pPr marL="457200" indent="0">
+              <a:buNone/>
+              <a:defRPr sz="1200"/>
+            </a:lvl2pPr>
+            <a:lvl3pPr marL="914400" indent="0">
+              <a:buNone/>
+              <a:defRPr sz="1000"/>
+            </a:lvl3pPr>
+            <a:lvl4pPr marL="1371600" indent="0">
+              <a:buNone/>
+              <a:defRPr sz="900"/>
+            </a:lvl4pPr>
+            <a:lvl5pPr marL="1828800" indent="0">
+              <a:buNone/>
+              <a:defRPr sz="900"/>
+            </a:lvl5pPr>
+            <a:lvl6pPr marL="2286000" indent="0">
+              <a:buNone/>
+              <a:defRPr sz="900"/>
+            </a:lvl6pPr>
+            <a:lvl7pPr marL="2743200" indent="0">
+              <a:buNone/>
+              <a:defRPr sz="900"/>
+            </a:lvl7pPr>
+            <a:lvl8pPr marL="3200400" indent="0">
+              <a:buNone/>
+              <a:defRPr sz="900"/>
+            </a:lvl8pPr>
+            <a:lvl9pPr marL="3657600" indent="0">
+              <a:buNone/>
+              <a:defRPr sz="900"/>
+            </a:lvl9pPr>
+          </a:lstStyle>
+          <a:p>
+            <a:pPr lvl="0"/>
+            <a:r>
+              <a:rPr lang="en-US" smtClean="0"/>
+              <a:t>Click to edit Master text styles</a:t>
+            </a:r>
+          </a:p>
+        </p:txBody>
+      </p:sp>
+      <p:sp>
+        <p:nvSpPr>
+          <p:cNvPr id="3" name="Date Placeholder 2"/>
+          <p:cNvSpPr>
+            <a:spLocks noGrp="1"/>
+          </p:cNvSpPr>
+          <p:nvPr>
+            <p:ph type="dt" sz="half" idx="10"/>
+          </p:nvPr>
+        </p:nvSpPr>
+        <p:spPr/>
+        <p:txBody>
+          <a:bodyPr/>
+          <a:lstStyle/>
+          <a:p>
+            <a:fld id="{5BCAD085-E8A6-8845-BD4E-CB4CCA059FC4}" type="datetimeFigureOut">
+              <a:rPr lang="en-US" smtClean="0"/>
+              <a:t>10/8/2026</a:t>
+            </a:fld>
+            <a:endParaRPr lang="en-US"/>
+          </a:p>
+        </p:txBody>
+      </p:sp>
+      <p:sp>
+        <p:nvSpPr>
+          <p:cNvPr id="4" name="Footer Placeholder 3"/>
+          <p:cNvSpPr>
+            <a:spLocks noGrp="1"/>
+          </p:cNvSpPr>
+          <p:nvPr>
+            <p:ph type="ftr" sz="quarter" idx="11"/>
+          </p:nvPr>
+        </p:nvSpPr>
+        <p:spPr/>
+        <p:txBody>
+          <a:bodyPr/>
+          <a:lstStyle/>
+          <a:p>
+            <a:endParaRPr lang="en-US"/>
+          </a:p>
+        </p:txBody>
+      </p:sp>
+      <p:sp>
+        <p:nvSpPr>
+          <p:cNvPr id="5" name="Slide Number Placeholder 4"/>
+          <p:cNvSpPr>
+            <a:spLocks noGrp="1"/>
+          </p:cNvSpPr>
+          <p:nvPr>
+            <p:ph type="sldNum" sz="quarter" idx="12"/>
+          </p:nvPr>
+        </p:nvSpPr>
+        <p:spPr/>
+        <p:txBody>
+          <a:bodyPr/>
+          <a:lstStyle/>
+          <a:p>
+            <a:fld id="{C1FF6DA9-008F-8B48-92A6-B652298478BF}" type="slidenum">
+              <a:rPr lang="en-US" smtClean="0"/>
+              <a:t>‹#›</a:t>
+            </a:fld>
+            <a:endParaRPr lang="en-US"/>
+          </a:p>
+        </p:txBody>
+      </p:sp>
+    </p:spTree>
+    <p:extLst>
+      <p:ext uri="{BB962C8B-B14F-4D97-AF65-F5344CB8AC3E}">
+        <p14:creationId xmlns:p14="http://schemas.microsoft.com/office/powerpoint/2010/main" val="1048637777"/>
+      </p:ext>
+    </p:extLst>
+  </p:cSld>
+  <p:clrMapOvr>
+    <a:masterClrMapping/>
+  </p:clrMapOvr>
+</p:sldLayout>
+</file>
+
+<file path=ppt/slideLayouts/slideLayout15.xml><?xml version="1.0" encoding="utf-8"?>
+<p:sldLayout xmlns:a="http://schemas.openxmlformats.org/drawingml/2006/main" xmlns:r="http://schemas.openxmlformats.org/officeDocument/2006/relationships" xmlns:p="http://schemas.openxmlformats.org/presentationml/2006/main" preserve="1">
+  <p:cSld name="3 Picture Column">
+    <p:spTree>
+      <p:nvGrpSpPr>
+        <p:cNvPr id="1" name=""/>
+        <p:cNvGrpSpPr/>
+        <p:nvPr/>
+      </p:nvGrpSpPr>
+      <p:grpSpPr>
+        <a:xfrm>
+          <a:off x="0" y="0"/>
+          <a:ext cx="0" cy="0"/>
+          <a:chOff x="0" y="0"/>
+          <a:chExt cx="0" cy="0"/>
+        </a:xfrm>
+      </p:grpSpPr>
+      <p:sp>
+        <p:nvSpPr>
+          <p:cNvPr id="30" name="Title 1"/>
+          <p:cNvSpPr>
+            <a:spLocks noGrp="1"/>
+          </p:cNvSpPr>
+          <p:nvPr>
+            <p:ph type="title"/>
+          </p:nvPr>
+        </p:nvSpPr>
+        <p:spPr>
+          <a:xfrm>
+            <a:off x="913795" y="609600"/>
+            <a:ext cx="10353762" cy="1325563"/>
+          </a:xfrm>
+        </p:spPr>
+        <p:txBody>
+          <a:bodyPr/>
+          <a:lstStyle/>
+          <a:p>
+            <a:r>
+              <a:rPr lang="en-US" smtClean="0"/>
+              <a:t>Click to edit Master title style</a:t>
+            </a:r>
+            <a:endParaRPr lang="en-US" dirty="0"/>
+          </a:p>
+        </p:txBody>
+      </p:sp>
+      <p:sp>
+        <p:nvSpPr>
+          <p:cNvPr id="19" name="Text Placeholder 2"/>
+          <p:cNvSpPr>
+            <a:spLocks noGrp="1"/>
+          </p:cNvSpPr>
+          <p:nvPr>
+            <p:ph type="body" idx="1"/>
+          </p:nvPr>
+        </p:nvSpPr>
+        <p:spPr>
+          <a:xfrm>
+            <a:off x="913795" y="4195899"/>
+            <a:ext cx="3298955" cy="576262"/>
+          </a:xfrm>
+        </p:spPr>
+        <p:txBody>
+          <a:bodyPr anchor="b">
+            <a:noAutofit/>
+          </a:bodyPr>
+          <a:lstStyle>
+            <a:lvl1pPr marL="0" indent="0" algn="ctr">
+              <a:lnSpc>
+                <a:spcPct val="100000"/>
+              </a:lnSpc>
+              <a:buNone/>
+              <a:defRPr sz="2000" b="0">
+                <a:solidFill>
+                  <a:schemeClr val="tx1"/>
+                </a:solidFill>
+              </a:defRPr>
+            </a:lvl1pPr>
+            <a:lvl2pPr marL="457200" indent="0">
+              <a:buNone/>
+              <a:defRPr sz="2000" b="1"/>
+            </a:lvl2pPr>
+            <a:lvl3pPr marL="914400" indent="0">
+              <a:buNone/>
+              <a:defRPr sz="1800" b="1"/>
+            </a:lvl3pPr>
+            <a:lvl4pPr marL="1371600" indent="0">
+              <a:buNone/>
+              <a:defRPr sz="1600" b="1"/>
+            </a:lvl4pPr>
+            <a:lvl5pPr marL="1828800" indent="0">
+              <a:buNone/>
+              <a:defRPr sz="1600" b="1"/>
+            </a:lvl5pPr>
+            <a:lvl6pPr marL="2286000" indent="0">
+              <a:buNone/>
+              <a:defRPr sz="1600" b="1"/>
+            </a:lvl6pPr>
+            <a:lvl7pPr marL="2743200" indent="0">
+              <a:buNone/>
+              <a:defRPr sz="1600" b="1"/>
+            </a:lvl7pPr>
+            <a:lvl8pPr marL="3200400" indent="0">
+              <a:buNone/>
+              <a:defRPr sz="1600" b="1"/>
+            </a:lvl8pPr>
+            <a:lvl9pPr marL="3657600" indent="0">
+              <a:buNone/>
+              <a:defRPr sz="1600" b="1"/>
+            </a:lvl9pPr>
+          </a:lstStyle>
+          <a:p>
+            <a:pPr lvl="0"/>
+            <a:r>
+              <a:rPr lang="en-US" smtClean="0"/>
+              <a:t>Click to edit Master text styles</a:t>
+            </a:r>
+          </a:p>
+        </p:txBody>
+      </p:sp>
+      <p:sp>
+        <p:nvSpPr>
+          <p:cNvPr id="20" name="Picture Placeholder 2"/>
+          <p:cNvSpPr>
+            <a:spLocks noGrp="1" noChangeAspect="1"/>
+          </p:cNvSpPr>
+          <p:nvPr>
+            <p:ph type="pic" idx="15"/>
+          </p:nvPr>
+        </p:nvSpPr>
+        <p:spPr>
+          <a:xfrm>
+            <a:off x="1092020" y="2298987"/>
+            <a:ext cx="2940050" cy="1524000"/>
+          </a:xfrm>
+          <a:prstGeom prst="roundRect">
+            <a:avLst>
+              <a:gd name="adj" fmla="val 0"/>
+            </a:avLst>
+          </a:prstGeom>
+          <a:noFill/>
+          <a:ln w="146050" cap="sq">
+            <a:solidFill>
+              <a:srgbClr val="FFFFFF"/>
+            </a:solidFill>
+            <a:miter lim="800000"/>
+          </a:ln>
+          <a:effectLst>
+            <a:outerShdw blurRad="55000" dist="18000" dir="5400000" algn="tl" rotWithShape="0">
+              <a:srgbClr val="000000">
+                <a:alpha val="40000"/>
+              </a:srgbClr>
+            </a:outerShdw>
+          </a:effectLst>
+          <a:scene3d>
+            <a:camera prst="orthographicFront"/>
+            <a:lightRig rig="twoPt" dir="t">
+              <a:rot lat="0" lon="0" rev="7200000"/>
+            </a:lightRig>
+          </a:scene3d>
+          <a:sp3d>
+            <a:bevelT w="25400" h="19050"/>
+            <a:contourClr>
+              <a:srgbClr val="FFFFFF"/>
+            </a:contourClr>
+          </a:sp3d>
+        </p:spPr>
+        <p:txBody>
+          <a:bodyPr anchor="t">
+            <a:normAutofit/>
+          </a:bodyPr>
+          <a:lstStyle>
+            <a:lvl1pPr marL="0" indent="0" algn="ctr">
+              <a:buNone/>
+              <a:defRPr sz="1600"/>
+            </a:lvl1pPr>
+            <a:lvl2pPr marL="457200" indent="0">
+              <a:buNone/>
+              <a:defRPr sz="1600"/>
+            </a:lvl2pPr>
+            <a:lvl3pPr marL="914400" indent="0">
+              <a:buNone/>
+              <a:defRPr sz="1600"/>
+            </a:lvl3pPr>
+            <a:lvl4pPr marL="1371600" indent="0">
+              <a:buNone/>
+              <a:defRPr sz="1600"/>
+            </a:lvl4pPr>
+            <a:lvl5pPr marL="1828800" indent="0">
+              <a:buNone/>
+              <a:defRPr sz="1600"/>
+            </a:lvl5pPr>
+            <a:lvl6pPr marL="2286000" indent="0">
+              <a:buNone/>
+              <a:defRPr sz="1600"/>
+            </a:lvl6pPr>
+            <a:lvl7pPr marL="2743200" indent="0">
+              <a:buNone/>
+              <a:defRPr sz="1600"/>
+            </a:lvl7pPr>
+            <a:lvl8pPr marL="3200400" indent="0">
+              <a:buNone/>
+              <a:defRPr sz="1600"/>
+            </a:lvl8pPr>
+            <a:lvl9pPr marL="3657600" indent="0">
+              <a:buNone/>
+              <a:defRPr sz="1600"/>
+            </a:lvl9pPr>
+          </a:lstStyle>
+          <a:p>
+            <a:r>
+              <a:rPr lang="en-US" smtClean="0"/>
+              <a:t>Click icon to add picture</a:t>
+            </a:r>
+            <a:endParaRPr lang="en-US" dirty="0"/>
+          </a:p>
+        </p:txBody>
+      </p:sp>
+      <p:sp>
+        <p:nvSpPr>
+          <p:cNvPr id="21" name="Text Placeholder 3"/>
+          <p:cNvSpPr>
+            <a:spLocks noGrp="1"/>
+          </p:cNvSpPr>
+          <p:nvPr>
+            <p:ph type="body" sz="half" idx="18"/>
+          </p:nvPr>
+        </p:nvSpPr>
+        <p:spPr>
+          <a:xfrm>
+            <a:off x="913795" y="4772161"/>
+            <a:ext cx="3298955" cy="1019038"/>
+          </a:xfrm>
+        </p:spPr>
+        <p:txBody>
+          <a:bodyPr anchor="t">
+            <a:normAutofit/>
+          </a:bodyPr>
+          <a:lstStyle>
+            <a:lvl1pPr marL="0" indent="0" algn="ctr">
+              <a:buNone/>
+              <a:defRPr sz="1400"/>
+            </a:lvl1pPr>
+            <a:lvl2pPr marL="457200" indent="0">
+              <a:buNone/>
+              <a:defRPr sz="1200"/>
+            </a:lvl2pPr>
+            <a:lvl3pPr marL="914400" indent="0">
+              <a:buNone/>
+              <a:defRPr sz="1000"/>
+            </a:lvl3pPr>
+            <a:lvl4pPr marL="1371600" indent="0">
+              <a:buNone/>
+              <a:defRPr sz="900"/>
+            </a:lvl4pPr>
+            <a:lvl5pPr marL="1828800" indent="0">
+              <a:buNone/>
+              <a:defRPr sz="900"/>
+            </a:lvl5pPr>
+            <a:lvl6pPr marL="2286000" indent="0">
+              <a:buNone/>
+              <a:defRPr sz="900"/>
+            </a:lvl6pPr>
+            <a:lvl7pPr marL="2743200" indent="0">
+              <a:buNone/>
+              <a:defRPr sz="900"/>
+            </a:lvl7pPr>
+            <a:lvl8pPr marL="3200400" indent="0">
+              <a:buNone/>
+              <a:defRPr sz="900"/>
+            </a:lvl8pPr>
+            <a:lvl9pPr marL="3657600" indent="0">
+              <a:buNone/>
+              <a:defRPr sz="900"/>
+            </a:lvl9pPr>
+          </a:lstStyle>
+          <a:p>
+            <a:pPr lvl="0"/>
+            <a:r>
+              <a:rPr lang="en-US" smtClean="0"/>
+              <a:t>Click to edit Master text styles</a:t>
+            </a:r>
+          </a:p>
+        </p:txBody>
+      </p:sp>
+      <p:sp>
+        <p:nvSpPr>
+          <p:cNvPr id="22" name="Text Placeholder 4"/>
+          <p:cNvSpPr>
+            <a:spLocks noGrp="1"/>
+          </p:cNvSpPr>
+          <p:nvPr>
+            <p:ph type="body" sz="quarter" idx="3"/>
+          </p:nvPr>
+        </p:nvSpPr>
+        <p:spPr>
+          <a:xfrm>
+            <a:off x="4442701" y="4195899"/>
+            <a:ext cx="3298983" cy="576262"/>
+          </a:xfrm>
+        </p:spPr>
+        <p:txBody>
+          <a:bodyPr anchor="b">
+            <a:noAutofit/>
+          </a:bodyPr>
+          <a:lstStyle>
+            <a:lvl1pPr marL="0" indent="0" algn="ctr">
+              <a:lnSpc>
+                <a:spcPct val="100000"/>
+              </a:lnSpc>
+              <a:buNone/>
+              <a:defRPr sz="2000" b="0">
+                <a:solidFill>
+                  <a:schemeClr val="tx1"/>
+                </a:solidFill>
+              </a:defRPr>
+            </a:lvl1pPr>
+            <a:lvl2pPr marL="457200" indent="0">
+              <a:buNone/>
+              <a:defRPr sz="2000" b="1"/>
+            </a:lvl2pPr>
+            <a:lvl3pPr marL="914400" indent="0">
+              <a:buNone/>
+              <a:defRPr sz="1800" b="1"/>
+            </a:lvl3pPr>
+            <a:lvl4pPr marL="1371600" indent="0">
+              <a:buNone/>
+              <a:defRPr sz="1600" b="1"/>
+            </a:lvl4pPr>
+            <a:lvl5pPr marL="1828800" indent="0">
+              <a:buNone/>
+              <a:defRPr sz="1600" b="1"/>
+            </a:lvl5pPr>
+            <a:lvl6pPr marL="2286000" indent="0">
+              <a:buNone/>
+              <a:defRPr sz="1600" b="1"/>
+            </a:lvl6pPr>
+            <a:lvl7pPr marL="2743200" indent="0">
+              <a:buNone/>
+              <a:defRPr sz="1600" b="1"/>
+            </a:lvl7pPr>
+            <a:lvl8pPr marL="3200400" indent="0">
+              <a:buNone/>
+              <a:defRPr sz="1600" b="1"/>
+            </a:lvl8pPr>
+            <a:lvl9pPr marL="3657600" indent="0">
+              <a:buNone/>
+              <a:defRPr sz="1600" b="1"/>
+            </a:lvl9pPr>
+          </a:lstStyle>
+          <a:p>
+            <a:pPr lvl="0"/>
+            <a:r>
+              <a:rPr lang="en-US" smtClean="0"/>
+              <a:t>Click to edit Master text styles</a:t>
+            </a:r>
+          </a:p>
+        </p:txBody>
+      </p:sp>
+      <p:sp>
+        <p:nvSpPr>
+          <p:cNvPr id="23" name="Picture Placeholder 2"/>
+          <p:cNvSpPr>
+            <a:spLocks noGrp="1" noChangeAspect="1"/>
+          </p:cNvSpPr>
+          <p:nvPr>
+            <p:ph type="pic" idx="21"/>
+          </p:nvPr>
+        </p:nvSpPr>
+        <p:spPr>
+          <a:xfrm>
+            <a:off x="4568996" y="2298987"/>
+            <a:ext cx="2930525" cy="1524000"/>
+          </a:xfrm>
+          <a:prstGeom prst="roundRect">
+            <a:avLst>
+              <a:gd name="adj" fmla="val 0"/>
+            </a:avLst>
+          </a:prstGeom>
+          <a:noFill/>
+          <a:ln w="146050" cap="sq">
+            <a:solidFill>
+              <a:srgbClr val="FFFFFF"/>
+            </a:solidFill>
+            <a:miter lim="800000"/>
+          </a:ln>
+          <a:effectLst>
+            <a:outerShdw blurRad="55000" dist="18000" dir="5400000" algn="tl" rotWithShape="0">
+              <a:srgbClr val="000000">
+                <a:alpha val="40000"/>
+              </a:srgbClr>
+            </a:outerShdw>
+          </a:effectLst>
+          <a:scene3d>
+            <a:camera prst="orthographicFront"/>
+            <a:lightRig rig="twoPt" dir="t">
+              <a:rot lat="0" lon="0" rev="7200000"/>
+            </a:lightRig>
+          </a:scene3d>
+          <a:sp3d>
+            <a:bevelT w="25400" h="19050"/>
+            <a:contourClr>
+              <a:srgbClr val="FFFFFF"/>
+            </a:contourClr>
+          </a:sp3d>
+        </p:spPr>
+        <p:txBody>
+          <a:bodyPr anchor="t">
+            <a:normAutofit/>
+          </a:bodyPr>
+          <a:lstStyle>
+            <a:lvl1pPr marL="0" indent="0" algn="ctr">
+              <a:buNone/>
+              <a:defRPr sz="1600"/>
+            </a:lvl1pPr>
+            <a:lvl2pPr marL="457200" indent="0">
+              <a:buNone/>
+              <a:defRPr sz="1600"/>
+            </a:lvl2pPr>
+            <a:lvl3pPr marL="914400" indent="0">
+              <a:buNone/>
+              <a:defRPr sz="1600"/>
+            </a:lvl3pPr>
+            <a:lvl4pPr marL="1371600" indent="0">
+              <a:buNone/>
+              <a:defRPr sz="1600"/>
+            </a:lvl4pPr>
+            <a:lvl5pPr marL="1828800" indent="0">
+              <a:buNone/>
+              <a:defRPr sz="1600"/>
+            </a:lvl5pPr>
+            <a:lvl6pPr marL="2286000" indent="0">
+              <a:buNone/>
+              <a:defRPr sz="1600"/>
+            </a:lvl6pPr>
+            <a:lvl7pPr marL="2743200" indent="0">
+              <a:buNone/>
+              <a:defRPr sz="1600"/>
+            </a:lvl7pPr>
+            <a:lvl8pPr marL="3200400" indent="0">
+              <a:buNone/>
+              <a:defRPr sz="1600"/>
+            </a:lvl8pPr>
+            <a:lvl9pPr marL="3657600" indent="0">
+              <a:buNone/>
+              <a:defRPr sz="1600"/>
+            </a:lvl9pPr>
+          </a:lstStyle>
+          <a:p>
+            <a:r>
+              <a:rPr lang="en-US" smtClean="0"/>
+              <a:t>Click icon to add picture</a:t>
+            </a:r>
+            <a:endParaRPr lang="en-US" dirty="0"/>
+          </a:p>
+        </p:txBody>
+      </p:sp>
+      <p:sp>
+        <p:nvSpPr>
+          <p:cNvPr id="24" name="Text Placeholder 3"/>
+          <p:cNvSpPr>
+            <a:spLocks noGrp="1"/>
+          </p:cNvSpPr>
+          <p:nvPr>
+            <p:ph type="body" sz="half" idx="19"/>
+          </p:nvPr>
+        </p:nvSpPr>
+        <p:spPr>
+          <a:xfrm>
+            <a:off x="4441348" y="4772160"/>
+            <a:ext cx="3300336" cy="1019038"/>
+          </a:xfrm>
+        </p:spPr>
+        <p:txBody>
+          <a:bodyPr anchor="t">
+            <a:normAutofit/>
+          </a:bodyPr>
+          <a:lstStyle>
+            <a:lvl1pPr marL="0" indent="0" algn="ctr">
+              <a:buNone/>
+              <a:defRPr sz="1400"/>
+            </a:lvl1pPr>
+            <a:lvl2pPr marL="457200" indent="0">
+              <a:buNone/>
+              <a:defRPr sz="1200"/>
+            </a:lvl2pPr>
+            <a:lvl3pPr marL="914400" indent="0">
+              <a:buNone/>
+              <a:defRPr sz="1000"/>
+            </a:lvl3pPr>
+            <a:lvl4pPr marL="1371600" indent="0">
+              <a:buNone/>
+              <a:defRPr sz="900"/>
+            </a:lvl4pPr>
+            <a:lvl5pPr marL="1828800" indent="0">
+              <a:buNone/>
+              <a:defRPr sz="900"/>
+            </a:lvl5pPr>
+            <a:lvl6pPr marL="2286000" indent="0">
+              <a:buNone/>
+              <a:defRPr sz="900"/>
+            </a:lvl6pPr>
+            <a:lvl7pPr marL="2743200" indent="0">
+              <a:buNone/>
+              <a:defRPr sz="900"/>
+            </a:lvl7pPr>
+            <a:lvl8pPr marL="3200400" indent="0">
+              <a:buNone/>
+              <a:defRPr sz="900"/>
+            </a:lvl8pPr>
+            <a:lvl9pPr marL="3657600" indent="0">
+              <a:buNone/>
+              <a:defRPr sz="900"/>
+            </a:lvl9pPr>
+          </a:lstStyle>
+          <a:p>
+            <a:pPr lvl="0"/>
+            <a:r>
+              <a:rPr lang="en-US" smtClean="0"/>
+              <a:t>Click to edit Master text styles</a:t>
+            </a:r>
+          </a:p>
+        </p:txBody>
+      </p:sp>
+      <p:sp>
+        <p:nvSpPr>
+          <p:cNvPr id="25" name="Text Placeholder 4"/>
+          <p:cNvSpPr>
+            <a:spLocks noGrp="1"/>
+          </p:cNvSpPr>
+          <p:nvPr>
+            <p:ph type="body" sz="quarter" idx="13"/>
+          </p:nvPr>
+        </p:nvSpPr>
+        <p:spPr>
+          <a:xfrm>
+            <a:off x="7973423" y="4195899"/>
+            <a:ext cx="3289900" cy="576262"/>
+          </a:xfrm>
+        </p:spPr>
+        <p:txBody>
+          <a:bodyPr anchor="b">
+            <a:noAutofit/>
+          </a:bodyPr>
+          <a:lstStyle>
+            <a:lvl1pPr marL="0" indent="0" algn="ctr">
+              <a:lnSpc>
+                <a:spcPct val="100000"/>
+              </a:lnSpc>
+              <a:buNone/>
+              <a:defRPr sz="2000" b="0">
+                <a:solidFill>
+                  <a:schemeClr val="tx1"/>
+                </a:solidFill>
+              </a:defRPr>
+            </a:lvl1pPr>
+            <a:lvl2pPr marL="457200" indent="0">
+              <a:buNone/>
+              <a:defRPr sz="2000" b="1"/>
+            </a:lvl2pPr>
+            <a:lvl3pPr marL="914400" indent="0">
+              <a:buNone/>
+              <a:defRPr sz="1800" b="1"/>
+            </a:lvl3pPr>
+            <a:lvl4pPr marL="1371600" indent="0">
+              <a:buNone/>
+              <a:defRPr sz="1600" b="1"/>
+            </a:lvl4pPr>
+            <a:lvl5pPr marL="1828800" indent="0">
+              <a:buNone/>
+              <a:defRPr sz="1600" b="1"/>
+            </a:lvl5pPr>
+            <a:lvl6pPr marL="2286000" indent="0">
+              <a:buNone/>
+              <a:defRPr sz="1600" b="1"/>
+            </a:lvl6pPr>
+            <a:lvl7pPr marL="2743200" indent="0">
+              <a:buNone/>
+              <a:defRPr sz="1600" b="1"/>
+            </a:lvl7pPr>
+            <a:lvl8pPr marL="3200400" indent="0">
+              <a:buNone/>
+              <a:defRPr sz="1600" b="1"/>
+            </a:lvl8pPr>
+            <a:lvl9pPr marL="3657600" indent="0">
+              <a:buNone/>
+              <a:defRPr sz="1600" b="1"/>
+            </a:lvl9pPr>
+          </a:lstStyle>
+          <a:p>
+            <a:pPr lvl="0"/>
+            <a:r>
+              <a:rPr lang="en-US" smtClean="0"/>
+              <a:t>Click to edit Master text styles</a:t>
+            </a:r>
+          </a:p>
+        </p:txBody>
+      </p:sp>
+      <p:sp>
+        <p:nvSpPr>
+          <p:cNvPr id="26" name="Picture Placeholder 2"/>
+          <p:cNvSpPr>
+            <a:spLocks noGrp="1" noChangeAspect="1"/>
+          </p:cNvSpPr>
+          <p:nvPr>
+            <p:ph type="pic" idx="22"/>
+          </p:nvPr>
+        </p:nvSpPr>
+        <p:spPr>
+          <a:xfrm>
+            <a:off x="8152803" y="2298987"/>
+            <a:ext cx="2932113" cy="1524000"/>
+          </a:xfrm>
+          <a:prstGeom prst="roundRect">
+            <a:avLst>
+              <a:gd name="adj" fmla="val 0"/>
+            </a:avLst>
+          </a:prstGeom>
+          <a:noFill/>
+          <a:ln w="146050" cap="sq">
+            <a:solidFill>
+              <a:srgbClr val="FFFFFF"/>
+            </a:solidFill>
+            <a:miter lim="800000"/>
+          </a:ln>
+          <a:effectLst>
+            <a:outerShdw blurRad="55000" dist="18000" dir="5400000" algn="tl" rotWithShape="0">
+              <a:srgbClr val="000000">
+                <a:alpha val="40000"/>
+              </a:srgbClr>
+            </a:outerShdw>
+          </a:effectLst>
+          <a:scene3d>
+            <a:camera prst="orthographicFront"/>
+            <a:lightRig rig="twoPt" dir="t">
+              <a:rot lat="0" lon="0" rev="7200000"/>
+            </a:lightRig>
+          </a:scene3d>
+          <a:sp3d>
+            <a:bevelT w="25400" h="19050"/>
+            <a:contourClr>
+              <a:srgbClr val="FFFFFF"/>
+            </a:contourClr>
+          </a:sp3d>
+        </p:spPr>
+        <p:txBody>
+          <a:bodyPr anchor="t">
+            <a:normAutofit/>
+          </a:bodyPr>
+          <a:lstStyle>
+            <a:lvl1pPr marL="0" indent="0" algn="ctr">
+              <a:buNone/>
+              <a:defRPr sz="1600"/>
+            </a:lvl1pPr>
+            <a:lvl2pPr marL="457200" indent="0">
+              <a:buNone/>
+              <a:defRPr sz="1600"/>
+            </a:lvl2pPr>
+            <a:lvl3pPr marL="914400" indent="0">
+              <a:buNone/>
+              <a:defRPr sz="1600"/>
+            </a:lvl3pPr>
+            <a:lvl4pPr marL="1371600" indent="0">
+              <a:buNone/>
+              <a:defRPr sz="1600"/>
+            </a:lvl4pPr>
+            <a:lvl5pPr marL="1828800" indent="0">
+              <a:buNone/>
+              <a:defRPr sz="1600"/>
+            </a:lvl5pPr>
+            <a:lvl6pPr marL="2286000" indent="0">
+              <a:buNone/>
+              <a:defRPr sz="1600"/>
+            </a:lvl6pPr>
+            <a:lvl7pPr marL="2743200" indent="0">
+              <a:buNone/>
+              <a:defRPr sz="1600"/>
+            </a:lvl7pPr>
+            <a:lvl8pPr marL="3200400" indent="0">
+              <a:buNone/>
+              <a:defRPr sz="1600"/>
+            </a:lvl8pPr>
+            <a:lvl9pPr marL="3657600" indent="0">
+              <a:buNone/>
+              <a:defRPr sz="1600"/>
+            </a:lvl9pPr>
+          </a:lstStyle>
+          <a:p>
+            <a:r>
+              <a:rPr lang="en-US" smtClean="0"/>
+              <a:t>Click icon to add picture</a:t>
+            </a:r>
+            <a:endParaRPr lang="en-US" dirty="0"/>
+          </a:p>
+        </p:txBody>
+      </p:sp>
+      <p:sp>
+        <p:nvSpPr>
+          <p:cNvPr id="27" name="Text Placeholder 3"/>
+          <p:cNvSpPr>
+            <a:spLocks noGrp="1"/>
+          </p:cNvSpPr>
+          <p:nvPr>
+            <p:ph type="body" sz="half" idx="20"/>
+          </p:nvPr>
+        </p:nvSpPr>
+        <p:spPr>
+          <a:xfrm>
+            <a:off x="7973298" y="4772161"/>
+            <a:ext cx="3294258" cy="1019037"/>
+          </a:xfrm>
+        </p:spPr>
+        <p:txBody>
+          <a:bodyPr anchor="t">
+            <a:normAutofit/>
+          </a:bodyPr>
+          <a:lstStyle>
+            <a:lvl1pPr marL="0" indent="0" algn="ctr">
+              <a:buNone/>
+              <a:defRPr sz="1400"/>
+            </a:lvl1pPr>
+            <a:lvl2pPr marL="457200" indent="0">
+              <a:buNone/>
+              <a:defRPr sz="1200"/>
+            </a:lvl2pPr>
+            <a:lvl3pPr marL="914400" indent="0">
+              <a:buNone/>
+              <a:defRPr sz="1000"/>
+            </a:lvl3pPr>
+            <a:lvl4pPr marL="1371600" indent="0">
+              <a:buNone/>
+              <a:defRPr sz="900"/>
+            </a:lvl4pPr>
+            <a:lvl5pPr marL="1828800" indent="0">
+              <a:buNone/>
+              <a:defRPr sz="900"/>
+            </a:lvl5pPr>
+            <a:lvl6pPr marL="2286000" indent="0">
+              <a:buNone/>
+              <a:defRPr sz="900"/>
+            </a:lvl6pPr>
+            <a:lvl7pPr marL="2743200" indent="0">
+              <a:buNone/>
+              <a:defRPr sz="900"/>
+            </a:lvl7pPr>
+            <a:lvl8pPr marL="3200400" indent="0">
+              <a:buNone/>
+              <a:defRPr sz="900"/>
+            </a:lvl8pPr>
+            <a:lvl9pPr marL="3657600" indent="0">
+              <a:buNone/>
+              <a:defRPr sz="900"/>
+            </a:lvl9pPr>
+          </a:lstStyle>
+          <a:p>
+            <a:pPr lvl="0"/>
+            <a:r>
+              <a:rPr lang="en-US" smtClean="0"/>
+              <a:t>Click to edit Master text styles</a:t>
+            </a:r>
+          </a:p>
+        </p:txBody>
+      </p:sp>
+      <p:sp>
+        <p:nvSpPr>
+          <p:cNvPr id="3" name="Date Placeholder 2"/>
+          <p:cNvSpPr>
+            <a:spLocks noGrp="1"/>
+          </p:cNvSpPr>
+          <p:nvPr>
+            <p:ph type="dt" sz="half" idx="10"/>
+          </p:nvPr>
+        </p:nvSpPr>
+        <p:spPr/>
+        <p:txBody>
+          <a:bodyPr/>
+          <a:lstStyle/>
+          <a:p>
+            <a:fld id="{5BCAD085-E8A6-8845-BD4E-CB4CCA059FC4}" type="datetimeFigureOut">
+              <a:rPr lang="en-US" smtClean="0"/>
+              <a:t>10/8/2026</a:t>
+            </a:fld>
+            <a:endParaRPr lang="en-US"/>
+          </a:p>
+        </p:txBody>
+      </p:sp>
+      <p:sp>
+        <p:nvSpPr>
+          <p:cNvPr id="4" name="Footer Placeholder 3"/>
+          <p:cNvSpPr>
+            <a:spLocks noGrp="1"/>
+          </p:cNvSpPr>
+          <p:nvPr>
+            <p:ph type="ftr" sz="quarter" idx="11"/>
+          </p:nvPr>
+        </p:nvSpPr>
+        <p:spPr/>
+        <p:txBody>
+          <a:bodyPr/>
+          <a:lstStyle/>
+          <a:p>
+            <a:endParaRPr lang="en-US"/>
+          </a:p>
+        </p:txBody>
+      </p:sp>
+      <p:sp>
+        <p:nvSpPr>
+          <p:cNvPr id="5" name="Slide Number Placeholder 4"/>
+          <p:cNvSpPr>
+            <a:spLocks noGrp="1"/>
+          </p:cNvSpPr>
+          <p:nvPr>
+            <p:ph type="sldNum" sz="quarter" idx="12"/>
+          </p:nvPr>
+        </p:nvSpPr>
+        <p:spPr/>
+        <p:txBody>
+          <a:bodyPr/>
+          <a:lstStyle/>
+          <a:p>
+            <a:fld id="{C1FF6DA9-008F-8B48-92A6-B652298478BF}" type="slidenum">
+              <a:rPr lang="en-US" smtClean="0"/>
+              <a:t>‹#›</a:t>
+            </a:fld>
+            <a:endParaRPr lang="en-US"/>
+          </a:p>
+        </p:txBody>
+      </p:sp>
+    </p:spTree>
+    <p:extLst>
+      <p:ext uri="{BB962C8B-B14F-4D97-AF65-F5344CB8AC3E}">
+        <p14:creationId xmlns:p14="http://schemas.microsoft.com/office/powerpoint/2010/main" val="289849352"/>
+      </p:ext>
+    </p:extLst>
+  </p:cSld>
+  <p:clrMapOvr>
+    <a:masterClrMapping/>
+  </p:clrMapOvr>
+</p:sldLayout>
+</file>
+
+<file path=ppt/slideLayouts/slideLayout16.xml><?xml version="1.0" encoding="utf-8"?>
 <p:sldLayout xmlns:a="http://schemas.openxmlformats.org/drawingml/2006/main" xmlns:r="http://schemas.openxmlformats.org/officeDocument/2006/relationships" xmlns:p="http://schemas.openxmlformats.org/presentationml/2006/main" type="vertTx" preserve="1">
   <p:cSld name="Title and Vertical Text">
     <p:spTree>
@@ -408,7 +2911,7 @@
               <a:rPr lang="en-US" smtClean="0"/>
               <a:t>Click to edit Master title style</a:t>
             </a:r>
-            <a:endParaRPr lang="en-US"/>
+            <a:endParaRPr lang="en-US" dirty="0"/>
           </a:p>
         </p:txBody>
       </p:sp>
@@ -460,7 +2963,7 @@
               <a:rPr lang="en-US" smtClean="0"/>
               <a:t>Fifth level</a:t>
             </a:r>
-            <a:endParaRPr lang="en-US"/>
+            <a:endParaRPr lang="en-US" dirty="0"/>
           </a:p>
         </p:txBody>
       </p:sp>
@@ -481,7 +2984,7 @@
           <a:p>
             <a:fld id="{5BCAD085-E8A6-8845-BD4E-CB4CCA059FC4}" type="datetimeFigureOut">
               <a:rPr lang="en-US" smtClean="0"/>
-              <a:t>10/4/2026</a:t>
+              <a:t>10/8/2026</a:t>
             </a:fld>
             <a:endParaRPr lang="en-US"/>
           </a:p>
@@ -532,7 +3035,7 @@
     </p:spTree>
     <p:extLst>
       <p:ext uri="{BB962C8B-B14F-4D97-AF65-F5344CB8AC3E}">
-        <p14:creationId xmlns:p14="http://schemas.microsoft.com/office/powerpoint/2010/main" val="2910927964"/>
+        <p14:creationId xmlns:p14="http://schemas.microsoft.com/office/powerpoint/2010/main" val="1026833781"/>
       </p:ext>
     </p:extLst>
   </p:cSld>
@@ -542,7 +3045,7 @@
 </p:sldLayout>
 </file>
 
-<file path=ppt/slideLayouts/slideLayout11.xml><?xml version="1.0" encoding="utf-8"?>
+<file path=ppt/slideLayouts/slideLayout17.xml><?xml version="1.0" encoding="utf-8"?>
 <p:sldLayout xmlns:a="http://schemas.openxmlformats.org/drawingml/2006/main" xmlns:r="http://schemas.openxmlformats.org/officeDocument/2006/relationships" xmlns:p="http://schemas.openxmlformats.org/presentationml/2006/main" type="vertTitleAndTx" preserve="1">
   <p:cSld name="Vertical Title and Text">
     <p:spTree>
@@ -571,19 +3074,23 @@
         </p:nvSpPr>
         <p:spPr>
           <a:xfrm>
-            <a:off x="6629400" y="274638"/>
-            <a:ext cx="2057400" cy="5851525"/>
+            <a:off x="8724900" y="609599"/>
+            <a:ext cx="2542657" cy="5181601"/>
           </a:xfrm>
         </p:spPr>
         <p:txBody>
           <a:bodyPr vert="eaVert"/>
-          <a:lstStyle/>
+          <a:lstStyle>
+            <a:lvl1pPr algn="l">
+              <a:defRPr/>
+            </a:lvl1pPr>
+          </a:lstStyle>
           <a:p>
             <a:r>
               <a:rPr lang="en-US" smtClean="0"/>
               <a:t>Click to edit Master title style</a:t>
             </a:r>
-            <a:endParaRPr lang="en-US"/>
+            <a:endParaRPr lang="en-US" dirty="0"/>
           </a:p>
         </p:txBody>
       </p:sp>
@@ -599,8 +3106,8 @@
         </p:nvSpPr>
         <p:spPr>
           <a:xfrm>
-            <a:off x="457200" y="274638"/>
-            <a:ext cx="6019800" cy="5851525"/>
+            <a:off x="913794" y="609599"/>
+            <a:ext cx="7658705" cy="5181601"/>
           </a:xfrm>
         </p:spPr>
         <p:txBody>
@@ -640,7 +3147,7 @@
               <a:rPr lang="en-US" smtClean="0"/>
               <a:t>Fifth level</a:t>
             </a:r>
-            <a:endParaRPr lang="en-US"/>
+            <a:endParaRPr lang="en-US" dirty="0"/>
           </a:p>
         </p:txBody>
       </p:sp>
@@ -661,7 +3168,7 @@
           <a:p>
             <a:fld id="{5BCAD085-E8A6-8845-BD4E-CB4CCA059FC4}" type="datetimeFigureOut">
               <a:rPr lang="en-US" smtClean="0"/>
-              <a:t>10/4/2026</a:t>
+              <a:t>10/8/2026</a:t>
             </a:fld>
             <a:endParaRPr lang="en-US"/>
           </a:p>
@@ -712,7 +3219,7 @@
     </p:spTree>
     <p:extLst>
       <p:ext uri="{BB962C8B-B14F-4D97-AF65-F5344CB8AC3E}">
-        <p14:creationId xmlns:p14="http://schemas.microsoft.com/office/powerpoint/2010/main" val="3612223792"/>
+        <p14:creationId xmlns:p14="http://schemas.microsoft.com/office/powerpoint/2010/main" val="4281150394"/>
       </p:ext>
     </p:extLst>
   </p:cSld>
@@ -758,7 +3265,7 @@
               <a:rPr lang="en-US" smtClean="0"/>
               <a:t>Click to edit Master title style</a:t>
             </a:r>
-            <a:endParaRPr lang="en-US"/>
+            <a:endParaRPr lang="en-US" dirty="0"/>
           </a:p>
         </p:txBody>
       </p:sp>
@@ -810,7 +3317,7 @@
               <a:rPr lang="en-US" smtClean="0"/>
               <a:t>Fifth level</a:t>
             </a:r>
-            <a:endParaRPr lang="en-US"/>
+            <a:endParaRPr lang="en-US" dirty="0"/>
           </a:p>
         </p:txBody>
       </p:sp>
@@ -831,7 +3338,7 @@
           <a:p>
             <a:fld id="{5BCAD085-E8A6-8845-BD4E-CB4CCA059FC4}" type="datetimeFigureOut">
               <a:rPr lang="en-US" smtClean="0"/>
-              <a:t>10/4/2026</a:t>
+              <a:t>10/8/2026</a:t>
             </a:fld>
             <a:endParaRPr lang="en-US"/>
           </a:p>
@@ -882,7 +3389,7 @@
     </p:spTree>
     <p:extLst>
       <p:ext uri="{BB962C8B-B14F-4D97-AF65-F5344CB8AC3E}">
-        <p14:creationId xmlns:p14="http://schemas.microsoft.com/office/powerpoint/2010/main" val="2614314258"/>
+        <p14:creationId xmlns:p14="http://schemas.microsoft.com/office/powerpoint/2010/main" val="3513168329"/>
       </p:ext>
     </p:extLst>
   </p:cSld>
@@ -921,15 +3428,17 @@
         </p:nvSpPr>
         <p:spPr>
           <a:xfrm>
-            <a:off x="722313" y="4406900"/>
-            <a:ext cx="7772400" cy="1362075"/>
-          </a:xfrm>
-        </p:spPr>
-        <p:txBody>
-          <a:bodyPr anchor="t"/>
+            <a:off x="1229244" y="657226"/>
+            <a:ext cx="9733512" cy="2852737"/>
+          </a:xfrm>
+        </p:spPr>
+        <p:txBody>
+          <a:bodyPr anchor="b">
+            <a:normAutofit/>
+          </a:bodyPr>
           <a:lstStyle>
-            <a:lvl1pPr algn="l">
-              <a:defRPr sz="4000" b="1" cap="all"/>
+            <a:lvl1pPr>
+              <a:defRPr sz="3400"/>
             </a:lvl1pPr>
           </a:lstStyle>
           <a:p>
@@ -937,7 +3446,7 @@
               <a:rPr lang="en-US" smtClean="0"/>
               <a:t>Click to edit Master title style</a:t>
             </a:r>
-            <a:endParaRPr lang="en-US"/>
+            <a:endParaRPr lang="en-US" dirty="0"/>
           </a:p>
         </p:txBody>
       </p:sp>
@@ -953,16 +3462,16 @@
         </p:nvSpPr>
         <p:spPr>
           <a:xfrm>
-            <a:off x="722313" y="2906713"/>
-            <a:ext cx="7772400" cy="1500187"/>
-          </a:xfrm>
-        </p:spPr>
-        <p:txBody>
-          <a:bodyPr anchor="b"/>
+            <a:off x="1229244" y="3602038"/>
+            <a:ext cx="9733512" cy="1500187"/>
+          </a:xfrm>
+        </p:spPr>
+        <p:txBody>
+          <a:bodyPr/>
           <a:lstStyle>
-            <a:lvl1pPr marL="0" indent="0">
-              <a:buNone/>
-              <a:defRPr sz="2000">
+            <a:lvl1pPr marL="0" indent="0" algn="ctr">
+              <a:buNone/>
+              <a:defRPr sz="2400">
                 <a:solidFill>
                   <a:schemeClr val="tx1">
                     <a:tint val="75000"/>
@@ -972,7 +3481,7 @@
             </a:lvl1pPr>
             <a:lvl2pPr marL="457200" indent="0">
               <a:buNone/>
-              <a:defRPr sz="1800">
+              <a:defRPr sz="2000">
                 <a:solidFill>
                   <a:schemeClr val="tx1">
                     <a:tint val="75000"/>
@@ -982,7 +3491,7 @@
             </a:lvl2pPr>
             <a:lvl3pPr marL="914400" indent="0">
               <a:buNone/>
-              <a:defRPr sz="1600">
+              <a:defRPr sz="1800">
                 <a:solidFill>
                   <a:schemeClr val="tx1">
                     <a:tint val="75000"/>
@@ -992,7 +3501,7 @@
             </a:lvl3pPr>
             <a:lvl4pPr marL="1371600" indent="0">
               <a:buNone/>
-              <a:defRPr sz="1400">
+              <a:defRPr sz="1600">
                 <a:solidFill>
                   <a:schemeClr val="tx1">
                     <a:tint val="75000"/>
@@ -1002,7 +3511,7 @@
             </a:lvl4pPr>
             <a:lvl5pPr marL="1828800" indent="0">
               <a:buNone/>
-              <a:defRPr sz="1400">
+              <a:defRPr sz="1600">
                 <a:solidFill>
                   <a:schemeClr val="tx1">
                     <a:tint val="75000"/>
@@ -1012,7 +3521,7 @@
             </a:lvl5pPr>
             <a:lvl6pPr marL="2286000" indent="0">
               <a:buNone/>
-              <a:defRPr sz="1400">
+              <a:defRPr sz="1600">
                 <a:solidFill>
                   <a:schemeClr val="tx1">
                     <a:tint val="75000"/>
@@ -1022,7 +3531,7 @@
             </a:lvl6pPr>
             <a:lvl7pPr marL="2743200" indent="0">
               <a:buNone/>
-              <a:defRPr sz="1400">
+              <a:defRPr sz="1600">
                 <a:solidFill>
                   <a:schemeClr val="tx1">
                     <a:tint val="75000"/>
@@ -1032,7 +3541,7 @@
             </a:lvl7pPr>
             <a:lvl8pPr marL="3200400" indent="0">
               <a:buNone/>
-              <a:defRPr sz="1400">
+              <a:defRPr sz="1600">
                 <a:solidFill>
                   <a:schemeClr val="tx1">
                     <a:tint val="75000"/>
@@ -1042,7 +3551,7 @@
             </a:lvl8pPr>
             <a:lvl9pPr marL="3657600" indent="0">
               <a:buNone/>
-              <a:defRPr sz="1400">
+              <a:defRPr sz="1600">
                 <a:solidFill>
                   <a:schemeClr val="tx1">
                     <a:tint val="75000"/>
@@ -1077,7 +3586,7 @@
           <a:p>
             <a:fld id="{5BCAD085-E8A6-8845-BD4E-CB4CCA059FC4}" type="datetimeFigureOut">
               <a:rPr lang="en-US" smtClean="0"/>
-              <a:t>10/4/2026</a:t>
+              <a:t>10/8/2026</a:t>
             </a:fld>
             <a:endParaRPr lang="en-US"/>
           </a:p>
@@ -1128,7 +3637,7 @@
     </p:spTree>
     <p:extLst>
       <p:ext uri="{BB962C8B-B14F-4D97-AF65-F5344CB8AC3E}">
-        <p14:creationId xmlns:p14="http://schemas.microsoft.com/office/powerpoint/2010/main" val="960648375"/>
+        <p14:creationId xmlns:p14="http://schemas.microsoft.com/office/powerpoint/2010/main" val="618246885"/>
       </p:ext>
     </p:extLst>
   </p:cSld>
@@ -1165,7 +3674,12 @@
             <p:ph type="title"/>
           </p:nvPr>
         </p:nvSpPr>
-        <p:spPr/>
+        <p:spPr>
+          <a:xfrm>
+            <a:off x="913795" y="609600"/>
+            <a:ext cx="10353761" cy="1326321"/>
+          </a:xfrm>
+        </p:spPr>
         <p:txBody>
           <a:bodyPr/>
           <a:lstStyle/>
@@ -1174,7 +3688,7 @@
               <a:rPr lang="en-US" smtClean="0"/>
               <a:t>Click to edit Master title style</a:t>
             </a:r>
-            <a:endParaRPr lang="en-US"/>
+            <a:endParaRPr lang="en-US" dirty="0"/>
           </a:p>
         </p:txBody>
       </p:sp>
@@ -1190,41 +3704,13 @@
         </p:nvSpPr>
         <p:spPr>
           <a:xfrm>
-            <a:off x="457200" y="1600200"/>
-            <a:ext cx="4038600" cy="4525963"/>
+            <a:off x="913795" y="2088319"/>
+            <a:ext cx="5106004" cy="3702881"/>
           </a:xfrm>
         </p:spPr>
         <p:txBody>
           <a:bodyPr/>
-          <a:lstStyle>
-            <a:lvl1pPr>
-              <a:defRPr sz="2800"/>
-            </a:lvl1pPr>
-            <a:lvl2pPr>
-              <a:defRPr sz="2400"/>
-            </a:lvl2pPr>
-            <a:lvl3pPr>
-              <a:defRPr sz="2000"/>
-            </a:lvl3pPr>
-            <a:lvl4pPr>
-              <a:defRPr sz="1800"/>
-            </a:lvl4pPr>
-            <a:lvl5pPr>
-              <a:defRPr sz="1800"/>
-            </a:lvl5pPr>
-            <a:lvl6pPr>
-              <a:defRPr sz="1800"/>
-            </a:lvl6pPr>
-            <a:lvl7pPr>
-              <a:defRPr sz="1800"/>
-            </a:lvl7pPr>
-            <a:lvl8pPr>
-              <a:defRPr sz="1800"/>
-            </a:lvl8pPr>
-            <a:lvl9pPr>
-              <a:defRPr sz="1800"/>
-            </a:lvl9pPr>
-          </a:lstStyle>
+          <a:lstStyle/>
           <a:p>
             <a:pPr lvl="0"/>
             <a:r>
@@ -1259,7 +3745,7 @@
               <a:rPr lang="en-US" smtClean="0"/>
               <a:t>Fifth level</a:t>
             </a:r>
-            <a:endParaRPr lang="en-US"/>
+            <a:endParaRPr lang="en-US" dirty="0"/>
           </a:p>
         </p:txBody>
       </p:sp>
@@ -1275,41 +3761,13 @@
         </p:nvSpPr>
         <p:spPr>
           <a:xfrm>
-            <a:off x="4648200" y="1600200"/>
-            <a:ext cx="4038600" cy="4525963"/>
+            <a:off x="6173403" y="2088319"/>
+            <a:ext cx="5094154" cy="3702881"/>
           </a:xfrm>
         </p:spPr>
         <p:txBody>
           <a:bodyPr/>
-          <a:lstStyle>
-            <a:lvl1pPr>
-              <a:defRPr sz="2800"/>
-            </a:lvl1pPr>
-            <a:lvl2pPr>
-              <a:defRPr sz="2400"/>
-            </a:lvl2pPr>
-            <a:lvl3pPr>
-              <a:defRPr sz="2000"/>
-            </a:lvl3pPr>
-            <a:lvl4pPr>
-              <a:defRPr sz="1800"/>
-            </a:lvl4pPr>
-            <a:lvl5pPr>
-              <a:defRPr sz="1800"/>
-            </a:lvl5pPr>
-            <a:lvl6pPr>
-              <a:defRPr sz="1800"/>
-            </a:lvl6pPr>
-            <a:lvl7pPr>
-              <a:defRPr sz="1800"/>
-            </a:lvl7pPr>
-            <a:lvl8pPr>
-              <a:defRPr sz="1800"/>
-            </a:lvl8pPr>
-            <a:lvl9pPr>
-              <a:defRPr sz="1800"/>
-            </a:lvl9pPr>
-          </a:lstStyle>
+          <a:lstStyle/>
           <a:p>
             <a:pPr lvl="0"/>
             <a:r>
@@ -1344,7 +3802,7 @@
               <a:rPr lang="en-US" smtClean="0"/>
               <a:t>Fifth level</a:t>
             </a:r>
-            <a:endParaRPr lang="en-US"/>
+            <a:endParaRPr lang="en-US" dirty="0"/>
           </a:p>
         </p:txBody>
       </p:sp>
@@ -1365,7 +3823,7 @@
           <a:p>
             <a:fld id="{5BCAD085-E8A6-8845-BD4E-CB4CCA059FC4}" type="datetimeFigureOut">
               <a:rPr lang="en-US" smtClean="0"/>
-              <a:t>10/4/2026</a:t>
+              <a:t>10/8/2026</a:t>
             </a:fld>
             <a:endParaRPr lang="en-US"/>
           </a:p>
@@ -1416,7 +3874,7 @@
     </p:spTree>
     <p:extLst>
       <p:ext uri="{BB962C8B-B14F-4D97-AF65-F5344CB8AC3E}">
-        <p14:creationId xmlns:p14="http://schemas.microsoft.com/office/powerpoint/2010/main" val="2782244947"/>
+        <p14:creationId xmlns:p14="http://schemas.microsoft.com/office/powerpoint/2010/main" val="2029881788"/>
       </p:ext>
     </p:extLst>
   </p:cSld>
@@ -1453,20 +3911,21 @@
             <p:ph type="title"/>
           </p:nvPr>
         </p:nvSpPr>
-        <p:spPr/>
+        <p:spPr>
+          <a:xfrm>
+            <a:off x="913795" y="609600"/>
+            <a:ext cx="10353761" cy="1325563"/>
+          </a:xfrm>
+        </p:spPr>
         <p:txBody>
           <a:bodyPr/>
-          <a:lstStyle>
-            <a:lvl1pPr>
-              <a:defRPr/>
-            </a:lvl1pPr>
-          </a:lstStyle>
+          <a:lstStyle/>
           <a:p>
             <a:r>
               <a:rPr lang="en-US" smtClean="0"/>
               <a:t>Click to edit Master title style</a:t>
             </a:r>
-            <a:endParaRPr lang="en-US"/>
+            <a:endParaRPr lang="en-US" dirty="0"/>
           </a:p>
         </p:txBody>
       </p:sp>
@@ -1482,14 +3941,17 @@
         </p:nvSpPr>
         <p:spPr>
           <a:xfrm>
-            <a:off x="457200" y="1535113"/>
-            <a:ext cx="4040188" cy="639762"/>
+            <a:off x="1141804" y="2088320"/>
+            <a:ext cx="4879199" cy="823912"/>
           </a:xfrm>
         </p:spPr>
         <p:txBody>
           <a:bodyPr anchor="b"/>
           <a:lstStyle>
             <a:lvl1pPr marL="0" indent="0">
+              <a:lnSpc>
+                <a:spcPct val="100000"/>
+              </a:lnSpc>
               <a:buNone/>
               <a:defRPr sz="2400" b="1"/>
             </a:lvl1pPr>
@@ -1547,41 +4009,13 @@
         </p:nvSpPr>
         <p:spPr>
           <a:xfrm>
-            <a:off x="457200" y="2174875"/>
-            <a:ext cx="4040188" cy="3951288"/>
+            <a:off x="913795" y="2912232"/>
+            <a:ext cx="5107208" cy="2878968"/>
           </a:xfrm>
         </p:spPr>
         <p:txBody>
           <a:bodyPr/>
-          <a:lstStyle>
-            <a:lvl1pPr>
-              <a:defRPr sz="2400"/>
-            </a:lvl1pPr>
-            <a:lvl2pPr>
-              <a:defRPr sz="2000"/>
-            </a:lvl2pPr>
-            <a:lvl3pPr>
-              <a:defRPr sz="1800"/>
-            </a:lvl3pPr>
-            <a:lvl4pPr>
-              <a:defRPr sz="1600"/>
-            </a:lvl4pPr>
-            <a:lvl5pPr>
-              <a:defRPr sz="1600"/>
-            </a:lvl5pPr>
-            <a:lvl6pPr>
-              <a:defRPr sz="1600"/>
-            </a:lvl6pPr>
-            <a:lvl7pPr>
-              <a:defRPr sz="1600"/>
-            </a:lvl7pPr>
-            <a:lvl8pPr>
-              <a:defRPr sz="1600"/>
-            </a:lvl8pPr>
-            <a:lvl9pPr>
-              <a:defRPr sz="1600"/>
-            </a:lvl9pPr>
-          </a:lstStyle>
+          <a:lstStyle/>
           <a:p>
             <a:pPr lvl="0"/>
             <a:r>
@@ -1616,7 +4050,7 @@
               <a:rPr lang="en-US" smtClean="0"/>
               <a:t>Fifth level</a:t>
             </a:r>
-            <a:endParaRPr lang="en-US"/>
+            <a:endParaRPr lang="en-US" dirty="0"/>
           </a:p>
         </p:txBody>
       </p:sp>
@@ -1632,14 +4066,17 @@
         </p:nvSpPr>
         <p:spPr>
           <a:xfrm>
-            <a:off x="4645025" y="1535113"/>
-            <a:ext cx="4041775" cy="639762"/>
+            <a:off x="6402003" y="2088320"/>
+            <a:ext cx="4865554" cy="823912"/>
           </a:xfrm>
         </p:spPr>
         <p:txBody>
           <a:bodyPr anchor="b"/>
           <a:lstStyle>
             <a:lvl1pPr marL="0" indent="0">
+              <a:lnSpc>
+                <a:spcPct val="100000"/>
+              </a:lnSpc>
               <a:buNone/>
               <a:defRPr sz="2400" b="1"/>
             </a:lvl1pPr>
@@ -1697,41 +4134,13 @@
         </p:nvSpPr>
         <p:spPr>
           <a:xfrm>
-            <a:off x="4645025" y="2174875"/>
-            <a:ext cx="4041775" cy="3951288"/>
+            <a:off x="6172200" y="2912232"/>
+            <a:ext cx="5095357" cy="2878968"/>
           </a:xfrm>
         </p:spPr>
         <p:txBody>
           <a:bodyPr/>
-          <a:lstStyle>
-            <a:lvl1pPr>
-              <a:defRPr sz="2400"/>
-            </a:lvl1pPr>
-            <a:lvl2pPr>
-              <a:defRPr sz="2000"/>
-            </a:lvl2pPr>
-            <a:lvl3pPr>
-              <a:defRPr sz="1800"/>
-            </a:lvl3pPr>
-            <a:lvl4pPr>
-              <a:defRPr sz="1600"/>
-            </a:lvl4pPr>
-            <a:lvl5pPr>
-              <a:defRPr sz="1600"/>
-            </a:lvl5pPr>
-            <a:lvl6pPr>
-              <a:defRPr sz="1600"/>
-            </a:lvl6pPr>
-            <a:lvl7pPr>
-              <a:defRPr sz="1600"/>
-            </a:lvl7pPr>
-            <a:lvl8pPr>
-              <a:defRPr sz="1600"/>
-            </a:lvl8pPr>
-            <a:lvl9pPr>
-              <a:defRPr sz="1600"/>
-            </a:lvl9pPr>
-          </a:lstStyle>
+          <a:lstStyle/>
           <a:p>
             <a:pPr lvl="0"/>
             <a:r>
@@ -1766,7 +4175,7 @@
               <a:rPr lang="en-US" smtClean="0"/>
               <a:t>Fifth level</a:t>
             </a:r>
-            <a:endParaRPr lang="en-US"/>
+            <a:endParaRPr lang="en-US" dirty="0"/>
           </a:p>
         </p:txBody>
       </p:sp>
@@ -1787,7 +4196,7 @@
           <a:p>
             <a:fld id="{5BCAD085-E8A6-8845-BD4E-CB4CCA059FC4}" type="datetimeFigureOut">
               <a:rPr lang="en-US" smtClean="0"/>
-              <a:t>10/4/2026</a:t>
+              <a:t>10/8/2026</a:t>
             </a:fld>
             <a:endParaRPr lang="en-US"/>
           </a:p>
@@ -1838,7 +4247,7 @@
     </p:spTree>
     <p:extLst>
       <p:ext uri="{BB962C8B-B14F-4D97-AF65-F5344CB8AC3E}">
-        <p14:creationId xmlns:p14="http://schemas.microsoft.com/office/powerpoint/2010/main" val="990158736"/>
+        <p14:creationId xmlns:p14="http://schemas.microsoft.com/office/powerpoint/2010/main" val="3142100346"/>
       </p:ext>
     </p:extLst>
   </p:cSld>
@@ -1884,7 +4293,7 @@
               <a:rPr lang="en-US" smtClean="0"/>
               <a:t>Click to edit Master title style</a:t>
             </a:r>
-            <a:endParaRPr lang="en-US"/>
+            <a:endParaRPr lang="en-US" dirty="0"/>
           </a:p>
         </p:txBody>
       </p:sp>
@@ -1905,7 +4314,7 @@
           <a:p>
             <a:fld id="{5BCAD085-E8A6-8845-BD4E-CB4CCA059FC4}" type="datetimeFigureOut">
               <a:rPr lang="en-US" smtClean="0"/>
-              <a:t>10/4/2026</a:t>
+              <a:t>10/8/2026</a:t>
             </a:fld>
             <a:endParaRPr lang="en-US"/>
           </a:p>
@@ -1956,7 +4365,7 @@
     </p:spTree>
     <p:extLst>
       <p:ext uri="{BB962C8B-B14F-4D97-AF65-F5344CB8AC3E}">
-        <p14:creationId xmlns:p14="http://schemas.microsoft.com/office/powerpoint/2010/main" val="727027711"/>
+        <p14:creationId xmlns:p14="http://schemas.microsoft.com/office/powerpoint/2010/main" val="1458948814"/>
       </p:ext>
     </p:extLst>
   </p:cSld>
@@ -2000,7 +4409,7 @@
           <a:p>
             <a:fld id="{5BCAD085-E8A6-8845-BD4E-CB4CCA059FC4}" type="datetimeFigureOut">
               <a:rPr lang="en-US" smtClean="0"/>
-              <a:t>10/4/2026</a:t>
+              <a:t>10/8/2026</a:t>
             </a:fld>
             <a:endParaRPr lang="en-US"/>
           </a:p>
@@ -2051,7 +4460,7 @@
     </p:spTree>
     <p:extLst>
       <p:ext uri="{BB962C8B-B14F-4D97-AF65-F5344CB8AC3E}">
-        <p14:creationId xmlns:p14="http://schemas.microsoft.com/office/powerpoint/2010/main" val="1212999818"/>
+        <p14:creationId xmlns:p14="http://schemas.microsoft.com/office/powerpoint/2010/main" val="481763093"/>
       </p:ext>
     </p:extLst>
   </p:cSld>
@@ -2090,15 +4499,17 @@
         </p:nvSpPr>
         <p:spPr>
           <a:xfrm>
-            <a:off x="457200" y="273050"/>
-            <a:ext cx="3008313" cy="1162050"/>
-          </a:xfrm>
-        </p:spPr>
-        <p:txBody>
-          <a:bodyPr anchor="b"/>
+            <a:off x="917228" y="609600"/>
+            <a:ext cx="3932237" cy="2362200"/>
+          </a:xfrm>
+        </p:spPr>
+        <p:txBody>
+          <a:bodyPr anchor="b">
+            <a:normAutofit/>
+          </a:bodyPr>
           <a:lstStyle>
-            <a:lvl1pPr algn="l">
-              <a:defRPr sz="2000" b="1"/>
+            <a:lvl1pPr>
+              <a:defRPr sz="2800"/>
             </a:lvl1pPr>
           </a:lstStyle>
           <a:p>
@@ -2106,7 +4517,7 @@
               <a:rPr lang="en-US" smtClean="0"/>
               <a:t>Click to edit Master title style</a:t>
             </a:r>
-            <a:endParaRPr lang="en-US"/>
+            <a:endParaRPr lang="en-US" dirty="0"/>
           </a:p>
         </p:txBody>
       </p:sp>
@@ -2122,41 +4533,13 @@
         </p:nvSpPr>
         <p:spPr>
           <a:xfrm>
-            <a:off x="3575050" y="273050"/>
-            <a:ext cx="5111750" cy="5853113"/>
-          </a:xfrm>
-        </p:spPr>
-        <p:txBody>
-          <a:bodyPr/>
-          <a:lstStyle>
-            <a:lvl1pPr>
-              <a:defRPr sz="3200"/>
-            </a:lvl1pPr>
-            <a:lvl2pPr>
-              <a:defRPr sz="2800"/>
-            </a:lvl2pPr>
-            <a:lvl3pPr>
-              <a:defRPr sz="2400"/>
-            </a:lvl3pPr>
-            <a:lvl4pPr>
-              <a:defRPr sz="2000"/>
-            </a:lvl4pPr>
-            <a:lvl5pPr>
-              <a:defRPr sz="2000"/>
-            </a:lvl5pPr>
-            <a:lvl6pPr>
-              <a:defRPr sz="2000"/>
-            </a:lvl6pPr>
-            <a:lvl7pPr>
-              <a:defRPr sz="2000"/>
-            </a:lvl7pPr>
-            <a:lvl8pPr>
-              <a:defRPr sz="2000"/>
-            </a:lvl8pPr>
-            <a:lvl9pPr>
-              <a:defRPr sz="2000"/>
-            </a:lvl9pPr>
-          </a:lstStyle>
+            <a:off x="5078064" y="609600"/>
+            <a:ext cx="6189492" cy="5181600"/>
+          </a:xfrm>
+        </p:spPr>
+        <p:txBody>
+          <a:bodyPr anchor="ctr"/>
+          <a:lstStyle/>
           <a:p>
             <a:pPr lvl="0"/>
             <a:r>
@@ -2191,7 +4574,7 @@
               <a:rPr lang="en-US" smtClean="0"/>
               <a:t>Fifth level</a:t>
             </a:r>
-            <a:endParaRPr lang="en-US"/>
+            <a:endParaRPr lang="en-US" dirty="0"/>
           </a:p>
         </p:txBody>
       </p:sp>
@@ -2207,48 +4590,48 @@
         </p:nvSpPr>
         <p:spPr>
           <a:xfrm>
-            <a:off x="457200" y="1435100"/>
-            <a:ext cx="3008313" cy="4691063"/>
+            <a:off x="917228" y="2971800"/>
+            <a:ext cx="3932237" cy="2819399"/>
           </a:xfrm>
         </p:spPr>
         <p:txBody>
           <a:bodyPr/>
           <a:lstStyle>
-            <a:lvl1pPr marL="0" indent="0">
-              <a:buNone/>
-              <a:defRPr sz="1400"/>
+            <a:lvl1pPr marL="0" indent="0" algn="ctr">
+              <a:buNone/>
+              <a:defRPr sz="1600"/>
             </a:lvl1pPr>
             <a:lvl2pPr marL="457200" indent="0">
               <a:buNone/>
-              <a:defRPr sz="1200"/>
+              <a:defRPr sz="1400"/>
             </a:lvl2pPr>
             <a:lvl3pPr marL="914400" indent="0">
               <a:buNone/>
-              <a:defRPr sz="1000"/>
+              <a:defRPr sz="1200"/>
             </a:lvl3pPr>
             <a:lvl4pPr marL="1371600" indent="0">
               <a:buNone/>
-              <a:defRPr sz="900"/>
+              <a:defRPr sz="1000"/>
             </a:lvl4pPr>
             <a:lvl5pPr marL="1828800" indent="0">
               <a:buNone/>
-              <a:defRPr sz="900"/>
+              <a:defRPr sz="1000"/>
             </a:lvl5pPr>
             <a:lvl6pPr marL="2286000" indent="0">
               <a:buNone/>
-              <a:defRPr sz="900"/>
+              <a:defRPr sz="1000"/>
             </a:lvl6pPr>
             <a:lvl7pPr marL="2743200" indent="0">
               <a:buNone/>
-              <a:defRPr sz="900"/>
+              <a:defRPr sz="1000"/>
             </a:lvl7pPr>
             <a:lvl8pPr marL="3200400" indent="0">
               <a:buNone/>
-              <a:defRPr sz="900"/>
+              <a:defRPr sz="1000"/>
             </a:lvl8pPr>
             <a:lvl9pPr marL="3657600" indent="0">
               <a:buNone/>
-              <a:defRPr sz="900"/>
+              <a:defRPr sz="1000"/>
             </a:lvl9pPr>
           </a:lstStyle>
           <a:p>
@@ -2277,7 +4660,7 @@
           <a:p>
             <a:fld id="{5BCAD085-E8A6-8845-BD4E-CB4CCA059FC4}" type="datetimeFigureOut">
               <a:rPr lang="en-US" smtClean="0"/>
-              <a:t>10/4/2026</a:t>
+              <a:t>10/8/2026</a:t>
             </a:fld>
             <a:endParaRPr lang="en-US"/>
           </a:p>
@@ -2328,7 +4711,7 @@
     </p:spTree>
     <p:extLst>
       <p:ext uri="{BB962C8B-B14F-4D97-AF65-F5344CB8AC3E}">
-        <p14:creationId xmlns:p14="http://schemas.microsoft.com/office/powerpoint/2010/main" val="1840726560"/>
+        <p14:creationId xmlns:p14="http://schemas.microsoft.com/office/powerpoint/2010/main" val="2931860934"/>
       </p:ext>
     </p:extLst>
   </p:cSld>
@@ -2367,15 +4750,17 @@
         </p:nvSpPr>
         <p:spPr>
           <a:xfrm>
-            <a:off x="1792288" y="4800600"/>
-            <a:ext cx="5486400" cy="566738"/>
-          </a:xfrm>
-        </p:spPr>
-        <p:txBody>
-          <a:bodyPr anchor="b"/>
+            <a:off x="917227" y="609600"/>
+            <a:ext cx="5929773" cy="2362200"/>
+          </a:xfrm>
+        </p:spPr>
+        <p:txBody>
+          <a:bodyPr anchor="b">
+            <a:normAutofit/>
+          </a:bodyPr>
           <a:lstStyle>
-            <a:lvl1pPr algn="l">
-              <a:defRPr sz="2000" b="1"/>
+            <a:lvl1pPr>
+              <a:defRPr sz="3200"/>
             </a:lvl1pPr>
           </a:lstStyle>
           <a:p>
@@ -2383,7 +4768,7 @@
               <a:rPr lang="en-US" smtClean="0"/>
               <a:t>Click to edit Master title style</a:t>
             </a:r>
-            <a:endParaRPr lang="en-US"/>
+            <a:endParaRPr lang="en-US" dirty="0"/>
           </a:p>
         </p:txBody>
       </p:sp>
@@ -2391,7 +4776,7 @@
         <p:nvSpPr>
           <p:cNvPr id="3" name="Picture Placeholder 2"/>
           <p:cNvSpPr>
-            <a:spLocks noGrp="1"/>
+            <a:spLocks noGrp="1" noChangeAspect="1"/>
           </p:cNvSpPr>
           <p:nvPr>
             <p:ph type="pic" idx="1"/>
@@ -2399,14 +4784,40 @@
         </p:nvSpPr>
         <p:spPr>
           <a:xfrm>
-            <a:off x="1792288" y="612775"/>
-            <a:ext cx="5486400" cy="4114800"/>
-          </a:xfrm>
-        </p:spPr>
-        <p:txBody>
-          <a:bodyPr/>
+            <a:off x="7424804" y="758881"/>
+            <a:ext cx="3255356" cy="4883038"/>
+          </a:xfrm>
+          <a:noFill/>
+          <a:ln w="190500" cap="sq">
+            <a:solidFill>
+              <a:srgbClr val="FFFFFF"/>
+            </a:solidFill>
+            <a:miter lim="800000"/>
+          </a:ln>
+          <a:effectLst>
+            <a:outerShdw blurRad="55000" dist="18000" dir="5400000" algn="tl" rotWithShape="0">
+              <a:srgbClr val="000000">
+                <a:alpha val="40000"/>
+              </a:srgbClr>
+            </a:outerShdw>
+          </a:effectLst>
+          <a:scene3d>
+            <a:camera prst="orthographicFront"/>
+            <a:lightRig rig="twoPt" dir="t">
+              <a:rot lat="0" lon="0" rev="7200000"/>
+            </a:lightRig>
+          </a:scene3d>
+          <a:sp3d>
+            <a:bevelT w="25400" h="19050"/>
+            <a:contourClr>
+              <a:srgbClr val="FFFFFF"/>
+            </a:contourClr>
+          </a:sp3d>
+        </p:spPr>
+        <p:txBody>
+          <a:bodyPr anchor="t"/>
           <a:lstStyle>
-            <a:lvl1pPr marL="0" indent="0">
+            <a:lvl1pPr marL="0" indent="0" algn="ctr">
               <a:buNone/>
               <a:defRPr sz="3200"/>
             </a:lvl1pPr>
@@ -2444,7 +4855,11 @@
             </a:lvl9pPr>
           </a:lstStyle>
           <a:p>
-            <a:endParaRPr lang="en-US"/>
+            <a:r>
+              <a:rPr lang="en-US" smtClean="0"/>
+              <a:t>Click icon to add picture</a:t>
+            </a:r>
+            <a:endParaRPr lang="en-US" dirty="0"/>
           </a:p>
         </p:txBody>
       </p:sp>
@@ -2460,48 +4875,50 @@
         </p:nvSpPr>
         <p:spPr>
           <a:xfrm>
-            <a:off x="1792288" y="5367338"/>
-            <a:ext cx="5486400" cy="804862"/>
-          </a:xfrm>
-        </p:spPr>
-        <p:txBody>
-          <a:bodyPr/>
+            <a:off x="913794" y="2971800"/>
+            <a:ext cx="5934950" cy="2819400"/>
+          </a:xfrm>
+        </p:spPr>
+        <p:txBody>
+          <a:bodyPr>
+            <a:normAutofit/>
+          </a:bodyPr>
           <a:lstStyle>
-            <a:lvl1pPr marL="0" indent="0">
-              <a:buNone/>
-              <a:defRPr sz="1400"/>
+            <a:lvl1pPr marL="0" indent="0" algn="ctr">
+              <a:buNone/>
+              <a:defRPr sz="1800"/>
             </a:lvl1pPr>
             <a:lvl2pPr marL="457200" indent="0">
               <a:buNone/>
-              <a:defRPr sz="1200"/>
+              <a:defRPr sz="1400"/>
             </a:lvl2pPr>
             <a:lvl3pPr marL="914400" indent="0">
               <a:buNone/>
-              <a:defRPr sz="1000"/>
+              <a:defRPr sz="1200"/>
             </a:lvl3pPr>
             <a:lvl4pPr marL="1371600" indent="0">
               <a:buNone/>
-              <a:defRPr sz="900"/>
+              <a:defRPr sz="1000"/>
             </a:lvl4pPr>
             <a:lvl5pPr marL="1828800" indent="0">
               <a:buNone/>
-              <a:defRPr sz="900"/>
+              <a:defRPr sz="1000"/>
             </a:lvl5pPr>
             <a:lvl6pPr marL="2286000" indent="0">
               <a:buNone/>
-              <a:defRPr sz="900"/>
+              <a:defRPr sz="1000"/>
             </a:lvl6pPr>
             <a:lvl7pPr marL="2743200" indent="0">
               <a:buNone/>
-              <a:defRPr sz="900"/>
+              <a:defRPr sz="1000"/>
             </a:lvl7pPr>
             <a:lvl8pPr marL="3200400" indent="0">
               <a:buNone/>
-              <a:defRPr sz="900"/>
+              <a:defRPr sz="1000"/>
             </a:lvl8pPr>
             <a:lvl9pPr marL="3657600" indent="0">
               <a:buNone/>
-              <a:defRPr sz="900"/>
+              <a:defRPr sz="1000"/>
             </a:lvl9pPr>
           </a:lstStyle>
           <a:p>
@@ -2530,7 +4947,7 @@
           <a:p>
             <a:fld id="{5BCAD085-E8A6-8845-BD4E-CB4CCA059FC4}" type="datetimeFigureOut">
               <a:rPr lang="en-US" smtClean="0"/>
-              <a:t>10/4/2026</a:t>
+              <a:t>10/8/2026</a:t>
             </a:fld>
             <a:endParaRPr lang="en-US"/>
           </a:p>
@@ -2581,7 +4998,7 @@
     </p:spTree>
     <p:extLst>
       <p:ext uri="{BB962C8B-B14F-4D97-AF65-F5344CB8AC3E}">
-        <p14:creationId xmlns:p14="http://schemas.microsoft.com/office/powerpoint/2010/main" val="3889236939"/>
+        <p14:creationId xmlns:p14="http://schemas.microsoft.com/office/powerpoint/2010/main" val="1961309702"/>
       </p:ext>
     </p:extLst>
   </p:cSld>
@@ -2595,8 +5012,8 @@
 <p:sldMaster xmlns:a="http://schemas.openxmlformats.org/drawingml/2006/main" xmlns:r="http://schemas.openxmlformats.org/officeDocument/2006/relationships" xmlns:p="http://schemas.openxmlformats.org/presentationml/2006/main">
   <p:cSld>
     <p:bg>
-      <p:bgRef idx="1001">
-        <a:schemeClr val="bg1"/>
+      <p:bgRef idx="1003">
+        <a:schemeClr val="bg2"/>
       </p:bgRef>
     </p:bg>
     <p:spTree>
@@ -2625,8 +5042,8 @@
         </p:nvSpPr>
         <p:spPr>
           <a:xfrm>
-            <a:off x="457200" y="274638"/>
-            <a:ext cx="8229600" cy="1143000"/>
+            <a:off x="913795" y="609600"/>
+            <a:ext cx="10353761" cy="1326321"/>
           </a:xfrm>
           <a:prstGeom prst="rect">
             <a:avLst/>
@@ -2642,7 +5059,7 @@
               <a:rPr lang="en-US" smtClean="0"/>
               <a:t>Click to edit Master title style</a:t>
             </a:r>
-            <a:endParaRPr lang="en-US"/>
+            <a:endParaRPr lang="en-US" dirty="0"/>
           </a:p>
         </p:txBody>
       </p:sp>
@@ -2658,8 +5075,8 @@
         </p:nvSpPr>
         <p:spPr>
           <a:xfrm>
-            <a:off x="457200" y="1600200"/>
-            <a:ext cx="8229600" cy="4525963"/>
+            <a:off x="913795" y="2096064"/>
+            <a:ext cx="10353762" cy="3695136"/>
           </a:xfrm>
           <a:prstGeom prst="rect">
             <a:avLst/>
@@ -2704,7 +5121,7 @@
               <a:rPr lang="en-US" smtClean="0"/>
               <a:t>Fifth level</a:t>
             </a:r>
-            <a:endParaRPr lang="en-US"/>
+            <a:endParaRPr lang="en-US" dirty="0"/>
           </a:p>
         </p:txBody>
       </p:sp>
@@ -2720,8 +5137,8 @@
         </p:nvSpPr>
         <p:spPr>
           <a:xfrm>
-            <a:off x="457200" y="6356350"/>
-            <a:ext cx="2133600" cy="365125"/>
+            <a:off x="7678736" y="5883275"/>
+            <a:ext cx="2743200" cy="365125"/>
           </a:xfrm>
           <a:prstGeom prst="rect">
             <a:avLst/>
@@ -2730,8 +5147,8 @@
         <p:txBody>
           <a:bodyPr vert="horz" lIns="91440" tIns="45720" rIns="91440" bIns="45720" rtlCol="0" anchor="ctr"/>
           <a:lstStyle>
-            <a:lvl1pPr algn="l">
-              <a:defRPr sz="1200">
+            <a:lvl1pPr algn="r">
+              <a:defRPr sz="1000">
                 <a:solidFill>
                   <a:schemeClr val="tx1">
                     <a:tint val="75000"/>
@@ -2743,7 +5160,7 @@
           <a:p>
             <a:fld id="{5BCAD085-E8A6-8845-BD4E-CB4CCA059FC4}" type="datetimeFigureOut">
               <a:rPr lang="en-US" smtClean="0"/>
-              <a:t>10/4/2026</a:t>
+              <a:t>10/8/2026</a:t>
             </a:fld>
             <a:endParaRPr lang="en-US"/>
           </a:p>
@@ -2761,8 +5178,8 @@
         </p:nvSpPr>
         <p:spPr>
           <a:xfrm>
-            <a:off x="3124200" y="6356350"/>
-            <a:ext cx="2895600" cy="365125"/>
+            <a:off x="913794" y="5883275"/>
+            <a:ext cx="6672865" cy="365125"/>
           </a:xfrm>
           <a:prstGeom prst="rect">
             <a:avLst/>
@@ -2771,8 +5188,8 @@
         <p:txBody>
           <a:bodyPr vert="horz" lIns="91440" tIns="45720" rIns="91440" bIns="45720" rtlCol="0" anchor="ctr"/>
           <a:lstStyle>
-            <a:lvl1pPr algn="ctr">
-              <a:defRPr sz="1200">
+            <a:lvl1pPr algn="l">
+              <a:defRPr sz="1000">
                 <a:solidFill>
                   <a:schemeClr val="tx1">
                     <a:tint val="75000"/>
@@ -2798,8 +5215,8 @@
         </p:nvSpPr>
         <p:spPr>
           <a:xfrm>
-            <a:off x="6553200" y="6356350"/>
-            <a:ext cx="2133600" cy="365125"/>
+            <a:off x="10514011" y="5883275"/>
+            <a:ext cx="753545" cy="365125"/>
           </a:xfrm>
           <a:prstGeom prst="rect">
             <a:avLst/>
@@ -2809,7 +5226,7 @@
           <a:bodyPr vert="horz" lIns="91440" tIns="45720" rIns="91440" bIns="45720" rtlCol="0" anchor="ctr"/>
           <a:lstStyle>
             <a:lvl1pPr algn="r">
-              <a:defRPr sz="1200">
+              <a:defRPr sz="1000">
                 <a:solidFill>
                   <a:schemeClr val="tx1">
                     <a:tint val="75000"/>
@@ -2830,35 +5247,51 @@
     </p:spTree>
     <p:extLst>
       <p:ext uri="{BB962C8B-B14F-4D97-AF65-F5344CB8AC3E}">
-        <p14:creationId xmlns:p14="http://schemas.microsoft.com/office/powerpoint/2010/main" val="2209977519"/>
+        <p14:creationId xmlns:p14="http://schemas.microsoft.com/office/powerpoint/2010/main" val="587688637"/>
       </p:ext>
     </p:extLst>
   </p:cSld>
-  <p:clrMap bg1="lt1" tx1="dk1" bg2="lt2" tx2="dk2" accent1="accent1" accent2="accent2" accent3="accent3" accent4="accent4" accent5="accent5" accent6="accent6" hlink="hlink" folHlink="folHlink"/>
+  <p:clrMap bg1="dk1" tx1="lt1" bg2="dk2" tx2="lt2" accent1="accent1" accent2="accent2" accent3="accent3" accent4="accent4" accent5="accent5" accent6="accent6" hlink="hlink" folHlink="folHlink"/>
   <p:sldLayoutIdLst>
-    <p:sldLayoutId id="2147483649" r:id="rId1"/>
-    <p:sldLayoutId id="2147483650" r:id="rId2"/>
-    <p:sldLayoutId id="2147483651" r:id="rId3"/>
-    <p:sldLayoutId id="2147483652" r:id="rId4"/>
-    <p:sldLayoutId id="2147483653" r:id="rId5"/>
-    <p:sldLayoutId id="2147483654" r:id="rId6"/>
-    <p:sldLayoutId id="2147483655" r:id="rId7"/>
-    <p:sldLayoutId id="2147483656" r:id="rId8"/>
-    <p:sldLayoutId id="2147483657" r:id="rId9"/>
-    <p:sldLayoutId id="2147483658" r:id="rId10"/>
-    <p:sldLayoutId id="2147483659" r:id="rId11"/>
+    <p:sldLayoutId id="2147483661" r:id="rId1"/>
+    <p:sldLayoutId id="2147483662" r:id="rId2"/>
+    <p:sldLayoutId id="2147483663" r:id="rId3"/>
+    <p:sldLayoutId id="2147483664" r:id="rId4"/>
+    <p:sldLayoutId id="2147483665" r:id="rId5"/>
+    <p:sldLayoutId id="2147483666" r:id="rId6"/>
+    <p:sldLayoutId id="2147483667" r:id="rId7"/>
+    <p:sldLayoutId id="2147483668" r:id="rId8"/>
+    <p:sldLayoutId id="2147483669" r:id="rId9"/>
+    <p:sldLayoutId id="2147483670" r:id="rId10"/>
+    <p:sldLayoutId id="2147483671" r:id="rId11"/>
+    <p:sldLayoutId id="2147483672" r:id="rId12"/>
+    <p:sldLayoutId id="2147483673" r:id="rId13"/>
+    <p:sldLayoutId id="2147483674" r:id="rId14"/>
+    <p:sldLayoutId id="2147483675" r:id="rId15"/>
+    <p:sldLayoutId id="2147483676" r:id="rId16"/>
+    <p:sldLayoutId id="2147483677" r:id="rId17"/>
   </p:sldLayoutIdLst>
   <p:txStyles>
     <p:titleStyle>
-      <a:lvl1pPr algn="ctr" defTabSz="457200" rtl="0" eaLnBrk="1" latinLnBrk="0" hangingPunct="1">
+      <a:lvl1pPr algn="ctr" defTabSz="914400" rtl="0" eaLnBrk="1" latinLnBrk="0" hangingPunct="1">
+        <a:lnSpc>
+          <a:spcPct val="90000"/>
+        </a:lnSpc>
         <a:spcBef>
           <a:spcPct val="0"/>
         </a:spcBef>
         <a:buNone/>
-        <a:defRPr sz="4400" kern="1200">
+        <a:defRPr sz="3400" b="1" i="0" kern="1200" cap="all">
           <a:solidFill>
             <a:schemeClr val="tx1"/>
           </a:solidFill>
+          <a:effectLst>
+            <a:outerShdw blurRad="50800" dist="63500" dir="2700000" algn="tl" rotWithShape="0">
+              <a:srgbClr val="000000">
+                <a:alpha val="48000"/>
+              </a:srgbClr>
+            </a:outerShdw>
+          </a:effectLst>
           <a:latin typeface="+mj-lt"/>
           <a:ea typeface="+mj-ea"/>
           <a:cs typeface="+mj-cs"/>
@@ -2866,136 +5299,226 @@
       </a:lvl1pPr>
     </p:titleStyle>
     <p:bodyStyle>
-      <a:lvl1pPr marL="342900" indent="-342900" algn="l" defTabSz="457200" rtl="0" eaLnBrk="1" latinLnBrk="0" hangingPunct="1">
+      <a:lvl1pPr marL="228600" indent="-228600" algn="l" defTabSz="914400" rtl="0" eaLnBrk="1" latinLnBrk="0" hangingPunct="1">
+        <a:lnSpc>
+          <a:spcPct val="120000"/>
+        </a:lnSpc>
         <a:spcBef>
-          <a:spcPct val="20000"/>
+          <a:spcPts val="1000"/>
         </a:spcBef>
-        <a:buFont typeface="Arial"/>
+        <a:buFont typeface="Arial" panose="020B0604020202020204" pitchFamily="34" charset="0"/>
         <a:buChar char="•"/>
-        <a:defRPr sz="3200" kern="1200">
+        <a:defRPr sz="2000" kern="1200">
           <a:solidFill>
             <a:schemeClr val="tx1"/>
           </a:solidFill>
+          <a:effectLst>
+            <a:outerShdw blurRad="50800" dist="38100" dir="2700000" algn="tl" rotWithShape="0">
+              <a:srgbClr val="000000">
+                <a:alpha val="48000"/>
+              </a:srgbClr>
+            </a:outerShdw>
+          </a:effectLst>
           <a:latin typeface="+mn-lt"/>
           <a:ea typeface="+mn-ea"/>
           <a:cs typeface="+mn-cs"/>
         </a:defRPr>
       </a:lvl1pPr>
-      <a:lvl2pPr marL="742950" indent="-285750" algn="l" defTabSz="457200" rtl="0" eaLnBrk="1" latinLnBrk="0" hangingPunct="1">
+      <a:lvl2pPr marL="685800" indent="-228600" algn="l" defTabSz="914400" rtl="0" eaLnBrk="1" latinLnBrk="0" hangingPunct="1">
+        <a:lnSpc>
+          <a:spcPct val="120000"/>
+        </a:lnSpc>
         <a:spcBef>
-          <a:spcPct val="20000"/>
+          <a:spcPts val="500"/>
         </a:spcBef>
-        <a:buFont typeface="Arial"/>
-        <a:buChar char="–"/>
-        <a:defRPr sz="2800" kern="1200">
+        <a:buFont typeface="Arial" panose="020B0604020202020204" pitchFamily="34" charset="0"/>
+        <a:buChar char="•"/>
+        <a:defRPr sz="1800" kern="1200">
           <a:solidFill>
             <a:schemeClr val="tx1"/>
           </a:solidFill>
+          <a:effectLst>
+            <a:outerShdw blurRad="50800" dist="38100" dir="2700000" algn="tl" rotWithShape="0">
+              <a:srgbClr val="000000">
+                <a:alpha val="48000"/>
+              </a:srgbClr>
+            </a:outerShdw>
+          </a:effectLst>
           <a:latin typeface="+mn-lt"/>
           <a:ea typeface="+mn-ea"/>
           <a:cs typeface="+mn-cs"/>
         </a:defRPr>
       </a:lvl2pPr>
-      <a:lvl3pPr marL="1143000" indent="-228600" algn="l" defTabSz="457200" rtl="0" eaLnBrk="1" latinLnBrk="0" hangingPunct="1">
+      <a:lvl3pPr marL="1143000" indent="-228600" algn="l" defTabSz="914400" rtl="0" eaLnBrk="1" latinLnBrk="0" hangingPunct="1">
+        <a:lnSpc>
+          <a:spcPct val="120000"/>
+        </a:lnSpc>
         <a:spcBef>
-          <a:spcPct val="20000"/>
+          <a:spcPts val="500"/>
         </a:spcBef>
-        <a:buFont typeface="Arial"/>
+        <a:buFont typeface="Arial" panose="020B0604020202020204" pitchFamily="34" charset="0"/>
         <a:buChar char="•"/>
-        <a:defRPr sz="2400" kern="1200">
+        <a:defRPr sz="1600" kern="1200">
           <a:solidFill>
             <a:schemeClr val="tx1"/>
           </a:solidFill>
+          <a:effectLst>
+            <a:outerShdw blurRad="50800" dist="38100" dir="2700000" algn="tl" rotWithShape="0">
+              <a:srgbClr val="000000">
+                <a:alpha val="48000"/>
+              </a:srgbClr>
+            </a:outerShdw>
+          </a:effectLst>
           <a:latin typeface="+mn-lt"/>
           <a:ea typeface="+mn-ea"/>
           <a:cs typeface="+mn-cs"/>
         </a:defRPr>
       </a:lvl3pPr>
-      <a:lvl4pPr marL="1600200" indent="-228600" algn="l" defTabSz="457200" rtl="0" eaLnBrk="1" latinLnBrk="0" hangingPunct="1">
+      <a:lvl4pPr marL="1600200" indent="-228600" algn="l" defTabSz="914400" rtl="0" eaLnBrk="1" latinLnBrk="0" hangingPunct="1">
+        <a:lnSpc>
+          <a:spcPct val="120000"/>
+        </a:lnSpc>
         <a:spcBef>
-          <a:spcPct val="20000"/>
+          <a:spcPts val="500"/>
         </a:spcBef>
-        <a:buFont typeface="Arial"/>
-        <a:buChar char="–"/>
-        <a:defRPr sz="2000" kern="1200">
+        <a:buFont typeface="Arial" panose="020B0604020202020204" pitchFamily="34" charset="0"/>
+        <a:buChar char="•"/>
+        <a:defRPr sz="1400" kern="1200">
           <a:solidFill>
             <a:schemeClr val="tx1"/>
           </a:solidFill>
+          <a:effectLst>
+            <a:outerShdw blurRad="50800" dist="38100" dir="2700000" algn="tl" rotWithShape="0">
+              <a:srgbClr val="000000">
+                <a:alpha val="48000"/>
+              </a:srgbClr>
+            </a:outerShdw>
+          </a:effectLst>
           <a:latin typeface="+mn-lt"/>
           <a:ea typeface="+mn-ea"/>
           <a:cs typeface="+mn-cs"/>
         </a:defRPr>
       </a:lvl4pPr>
-      <a:lvl5pPr marL="2057400" indent="-228600" algn="l" defTabSz="457200" rtl="0" eaLnBrk="1" latinLnBrk="0" hangingPunct="1">
+      <a:lvl5pPr marL="2057400" indent="-228600" algn="l" defTabSz="914400" rtl="0" eaLnBrk="1" latinLnBrk="0" hangingPunct="1">
+        <a:lnSpc>
+          <a:spcPct val="120000"/>
+        </a:lnSpc>
         <a:spcBef>
-          <a:spcPct val="20000"/>
+          <a:spcPts val="500"/>
         </a:spcBef>
-        <a:buFont typeface="Arial"/>
-        <a:buChar char="»"/>
-        <a:defRPr sz="2000" kern="1200">
+        <a:buFont typeface="Arial" panose="020B0604020202020204" pitchFamily="34" charset="0"/>
+        <a:buChar char="•"/>
+        <a:defRPr sz="1200" kern="1200">
           <a:solidFill>
             <a:schemeClr val="tx1"/>
           </a:solidFill>
+          <a:effectLst>
+            <a:outerShdw blurRad="50800" dist="38100" dir="2700000" algn="tl" rotWithShape="0">
+              <a:srgbClr val="000000">
+                <a:alpha val="48000"/>
+              </a:srgbClr>
+            </a:outerShdw>
+          </a:effectLst>
           <a:latin typeface="+mn-lt"/>
           <a:ea typeface="+mn-ea"/>
           <a:cs typeface="+mn-cs"/>
         </a:defRPr>
       </a:lvl5pPr>
-      <a:lvl6pPr marL="2514600" indent="-228600" algn="l" defTabSz="457200" rtl="0" eaLnBrk="1" latinLnBrk="0" hangingPunct="1">
+      <a:lvl6pPr marL="2514600" indent="-228600" algn="l" defTabSz="914400" rtl="0" eaLnBrk="1" latinLnBrk="0" hangingPunct="1">
+        <a:lnSpc>
+          <a:spcPct val="120000"/>
+        </a:lnSpc>
         <a:spcBef>
-          <a:spcPct val="20000"/>
+          <a:spcPts val="500"/>
         </a:spcBef>
-        <a:buFont typeface="Arial"/>
+        <a:buFont typeface="Arial" panose="020B0604020202020204" pitchFamily="34" charset="0"/>
         <a:buChar char="•"/>
-        <a:defRPr sz="2000" kern="1200">
+        <a:defRPr sz="1200" kern="1200">
           <a:solidFill>
             <a:schemeClr val="tx1"/>
           </a:solidFill>
+          <a:effectLst>
+            <a:outerShdw blurRad="50800" dist="38100" dir="2700000" algn="tl" rotWithShape="0">
+              <a:srgbClr val="000000">
+                <a:alpha val="48000"/>
+              </a:srgbClr>
+            </a:outerShdw>
+          </a:effectLst>
           <a:latin typeface="+mn-lt"/>
           <a:ea typeface="+mn-ea"/>
           <a:cs typeface="+mn-cs"/>
         </a:defRPr>
       </a:lvl6pPr>
-      <a:lvl7pPr marL="2971800" indent="-228600" algn="l" defTabSz="457200" rtl="0" eaLnBrk="1" latinLnBrk="0" hangingPunct="1">
+      <a:lvl7pPr marL="2971800" indent="-228600" algn="l" defTabSz="914400" rtl="0" eaLnBrk="1" latinLnBrk="0" hangingPunct="1">
+        <a:lnSpc>
+          <a:spcPct val="120000"/>
+        </a:lnSpc>
         <a:spcBef>
-          <a:spcPct val="20000"/>
+          <a:spcPts val="500"/>
         </a:spcBef>
-        <a:buFont typeface="Arial"/>
+        <a:buFont typeface="Arial" panose="020B0604020202020204" pitchFamily="34" charset="0"/>
         <a:buChar char="•"/>
-        <a:defRPr sz="2000" kern="1200">
+        <a:defRPr sz="1200" kern="1200">
           <a:solidFill>
             <a:schemeClr val="tx1"/>
           </a:solidFill>
+          <a:effectLst>
+            <a:outerShdw blurRad="50800" dist="38100" dir="2700000" algn="tl" rotWithShape="0">
+              <a:srgbClr val="000000">
+                <a:alpha val="48000"/>
+              </a:srgbClr>
+            </a:outerShdw>
+          </a:effectLst>
           <a:latin typeface="+mn-lt"/>
           <a:ea typeface="+mn-ea"/>
           <a:cs typeface="+mn-cs"/>
         </a:defRPr>
       </a:lvl7pPr>
-      <a:lvl8pPr marL="3429000" indent="-228600" algn="l" defTabSz="457200" rtl="0" eaLnBrk="1" latinLnBrk="0" hangingPunct="1">
+      <a:lvl8pPr marL="3429000" indent="-228600" algn="l" defTabSz="914400" rtl="0" eaLnBrk="1" latinLnBrk="0" hangingPunct="1">
+        <a:lnSpc>
+          <a:spcPct val="120000"/>
+        </a:lnSpc>
         <a:spcBef>
-          <a:spcPct val="20000"/>
+          <a:spcPts val="500"/>
         </a:spcBef>
-        <a:buFont typeface="Arial"/>
+        <a:buFont typeface="Arial" panose="020B0604020202020204" pitchFamily="34" charset="0"/>
         <a:buChar char="•"/>
-        <a:defRPr sz="2000" kern="1200">
+        <a:defRPr sz="1200" kern="1200">
           <a:solidFill>
             <a:schemeClr val="tx1"/>
           </a:solidFill>
+          <a:effectLst>
+            <a:outerShdw blurRad="50800" dist="38100" dir="2700000" algn="tl" rotWithShape="0">
+              <a:srgbClr val="000000">
+                <a:alpha val="48000"/>
+              </a:srgbClr>
+            </a:outerShdw>
+          </a:effectLst>
           <a:latin typeface="+mn-lt"/>
           <a:ea typeface="+mn-ea"/>
           <a:cs typeface="+mn-cs"/>
         </a:defRPr>
       </a:lvl8pPr>
-      <a:lvl9pPr marL="3886200" indent="-228600" algn="l" defTabSz="457200" rtl="0" eaLnBrk="1" latinLnBrk="0" hangingPunct="1">
+      <a:lvl9pPr marL="3886200" indent="-228600" algn="l" defTabSz="914400" rtl="0" eaLnBrk="1" latinLnBrk="0" hangingPunct="1">
+        <a:lnSpc>
+          <a:spcPct val="120000"/>
+        </a:lnSpc>
         <a:spcBef>
-          <a:spcPct val="20000"/>
+          <a:spcPts val="500"/>
         </a:spcBef>
-        <a:buFont typeface="Arial"/>
+        <a:buFont typeface="Arial" panose="020B0604020202020204" pitchFamily="34" charset="0"/>
         <a:buChar char="•"/>
-        <a:defRPr sz="2000" kern="1200">
+        <a:defRPr sz="1200" kern="1200">
           <a:solidFill>
             <a:schemeClr val="tx1"/>
           </a:solidFill>
+          <a:effectLst>
+            <a:outerShdw blurRad="50800" dist="38100" dir="2700000" algn="tl" rotWithShape="0">
+              <a:srgbClr val="000000">
+                <a:alpha val="48000"/>
+              </a:srgbClr>
+            </a:outerShdw>
+          </a:effectLst>
           <a:latin typeface="+mn-lt"/>
           <a:ea typeface="+mn-ea"/>
           <a:cs typeface="+mn-cs"/>
@@ -3006,7 +5529,7 @@
       <a:defPPr>
         <a:defRPr lang="en-US"/>
       </a:defPPr>
-      <a:lvl1pPr marL="0" algn="l" defTabSz="457200" rtl="0" eaLnBrk="1" latinLnBrk="0" hangingPunct="1">
+      <a:lvl1pPr marL="0" algn="l" defTabSz="914400" rtl="0" eaLnBrk="1" latinLnBrk="0" hangingPunct="1">
         <a:defRPr sz="1800" kern="1200">
           <a:solidFill>
             <a:schemeClr val="tx1"/>
@@ -3016,7 +5539,7 @@
           <a:cs typeface="+mn-cs"/>
         </a:defRPr>
       </a:lvl1pPr>
-      <a:lvl2pPr marL="457200" algn="l" defTabSz="457200" rtl="0" eaLnBrk="1" latinLnBrk="0" hangingPunct="1">
+      <a:lvl2pPr marL="457200" algn="l" defTabSz="914400" rtl="0" eaLnBrk="1" latinLnBrk="0" hangingPunct="1">
         <a:defRPr sz="1800" kern="1200">
           <a:solidFill>
             <a:schemeClr val="tx1"/>
@@ -3026,7 +5549,7 @@
           <a:cs typeface="+mn-cs"/>
         </a:defRPr>
       </a:lvl2pPr>
-      <a:lvl3pPr marL="914400" algn="l" defTabSz="457200" rtl="0" eaLnBrk="1" latinLnBrk="0" hangingPunct="1">
+      <a:lvl3pPr marL="914400" algn="l" defTabSz="914400" rtl="0" eaLnBrk="1" latinLnBrk="0" hangingPunct="1">
         <a:defRPr sz="1800" kern="1200">
           <a:solidFill>
             <a:schemeClr val="tx1"/>
@@ -3036,7 +5559,7 @@
           <a:cs typeface="+mn-cs"/>
         </a:defRPr>
       </a:lvl3pPr>
-      <a:lvl4pPr marL="1371600" algn="l" defTabSz="457200" rtl="0" eaLnBrk="1" latinLnBrk="0" hangingPunct="1">
+      <a:lvl4pPr marL="1371600" algn="l" defTabSz="914400" rtl="0" eaLnBrk="1" latinLnBrk="0" hangingPunct="1">
         <a:defRPr sz="1800" kern="1200">
           <a:solidFill>
             <a:schemeClr val="tx1"/>
@@ -3046,7 +5569,7 @@
           <a:cs typeface="+mn-cs"/>
         </a:defRPr>
       </a:lvl4pPr>
-      <a:lvl5pPr marL="1828800" algn="l" defTabSz="457200" rtl="0" eaLnBrk="1" latinLnBrk="0" hangingPunct="1">
+      <a:lvl5pPr marL="1828800" algn="l" defTabSz="914400" rtl="0" eaLnBrk="1" latinLnBrk="0" hangingPunct="1">
         <a:defRPr sz="1800" kern="1200">
           <a:solidFill>
             <a:schemeClr val="tx1"/>
@@ -3056,7 +5579,7 @@
           <a:cs typeface="+mn-cs"/>
         </a:defRPr>
       </a:lvl5pPr>
-      <a:lvl6pPr marL="2286000" algn="l" defTabSz="457200" rtl="0" eaLnBrk="1" latinLnBrk="0" hangingPunct="1">
+      <a:lvl6pPr marL="2286000" algn="l" defTabSz="914400" rtl="0" eaLnBrk="1" latinLnBrk="0" hangingPunct="1">
         <a:defRPr sz="1800" kern="1200">
           <a:solidFill>
             <a:schemeClr val="tx1"/>
@@ -3066,7 +5589,7 @@
           <a:cs typeface="+mn-cs"/>
         </a:defRPr>
       </a:lvl6pPr>
-      <a:lvl7pPr marL="2743200" algn="l" defTabSz="457200" rtl="0" eaLnBrk="1" latinLnBrk="0" hangingPunct="1">
+      <a:lvl7pPr marL="2743200" algn="l" defTabSz="914400" rtl="0" eaLnBrk="1" latinLnBrk="0" hangingPunct="1">
         <a:defRPr sz="1800" kern="1200">
           <a:solidFill>
             <a:schemeClr val="tx1"/>
@@ -3076,7 +5599,7 @@
           <a:cs typeface="+mn-cs"/>
         </a:defRPr>
       </a:lvl7pPr>
-      <a:lvl8pPr marL="3200400" algn="l" defTabSz="457200" rtl="0" eaLnBrk="1" latinLnBrk="0" hangingPunct="1">
+      <a:lvl8pPr marL="3200400" algn="l" defTabSz="914400" rtl="0" eaLnBrk="1" latinLnBrk="0" hangingPunct="1">
         <a:defRPr sz="1800" kern="1200">
           <a:solidFill>
             <a:schemeClr val="tx1"/>
@@ -3086,7 +5609,7 @@
           <a:cs typeface="+mn-cs"/>
         </a:defRPr>
       </a:lvl8pPr>
-      <a:lvl9pPr marL="3657600" algn="l" defTabSz="457200" rtl="0" eaLnBrk="1" latinLnBrk="0" hangingPunct="1">
+      <a:lvl9pPr marL="3657600" algn="l" defTabSz="914400" rtl="0" eaLnBrk="1" latinLnBrk="0" hangingPunct="1">
         <a:defRPr sz="1800" kern="1200">
           <a:solidFill>
             <a:schemeClr val="tx1"/>
@@ -3789,6 +6312,13 @@
   <p:clrMapOvr>
     <a:masterClrMapping/>
   </p:clrMapOvr>
+  <p:timing>
+    <p:tnLst>
+      <p:par>
+        <p:cTn id="1" dur="indefinite" restart="never" nodeType="tmRoot"/>
+      </p:par>
+    </p:tnLst>
+  </p:timing>
 </p:sld>
 </file>
 
@@ -5013,6 +7543,13 @@
   <p:clrMapOvr>
     <a:masterClrMapping/>
   </p:clrMapOvr>
+  <p:timing>
+    <p:tnLst>
+      <p:par>
+        <p:cTn id="1" dur="indefinite" restart="never" nodeType="tmRoot"/>
+      </p:par>
+    </p:tnLst>
+  </p:timing>
 </p:sld>
 </file>
 
@@ -6126,6 +8663,13 @@
   <p:clrMapOvr>
     <a:masterClrMapping/>
   </p:clrMapOvr>
+  <p:timing>
+    <p:tnLst>
+      <p:par>
+        <p:cTn id="1" dur="indefinite" restart="never" nodeType="tmRoot"/>
+      </p:par>
+    </p:tnLst>
+  </p:timing>
 </p:sld>
 </file>
 
@@ -10514,6 +13058,13 @@
   <p:clrMapOvr>
     <a:masterClrMapping/>
   </p:clrMapOvr>
+  <p:timing>
+    <p:tnLst>
+      <p:par>
+        <p:cTn id="1" dur="indefinite" restart="never" nodeType="tmRoot"/>
+      </p:par>
+    </p:tnLst>
+  </p:timing>
 </p:sld>
 </file>
 
@@ -11474,13 +14025,92 @@
   <p:clrMapOvr>
     <a:masterClrMapping/>
   </p:clrMapOvr>
+  <p:timing>
+    <p:tnLst>
+      <p:par>
+        <p:cTn id="1" dur="indefinite" restart="never" nodeType="tmRoot"/>
+      </p:par>
+    </p:tnLst>
+  </p:timing>
+</p:sld>
+</file>
+
+<file path=ppt/slides/slide9.xml><?xml version="1.0" encoding="utf-8"?>
+<p:sld xmlns:a="http://schemas.openxmlformats.org/drawingml/2006/main" xmlns:r="http://schemas.openxmlformats.org/officeDocument/2006/relationships" xmlns:p="http://schemas.openxmlformats.org/presentationml/2006/main">
+  <p:cSld>
+    <p:spTree>
+      <p:nvGrpSpPr>
+        <p:cNvPr id="1" name=""/>
+        <p:cNvGrpSpPr/>
+        <p:nvPr/>
+      </p:nvGrpSpPr>
+      <p:grpSpPr>
+        <a:xfrm>
+          <a:off x="0" y="0"/>
+          <a:ext cx="0" cy="0"/>
+          <a:chOff x="0" y="0"/>
+          <a:chExt cx="0" cy="0"/>
+        </a:xfrm>
+      </p:grpSpPr>
+      <p:sp>
+        <p:nvSpPr>
+          <p:cNvPr id="2" name="Title 1"/>
+          <p:cNvSpPr>
+            <a:spLocks noGrp="1"/>
+          </p:cNvSpPr>
+          <p:nvPr>
+            <p:ph type="title"/>
+          </p:nvPr>
+        </p:nvSpPr>
+        <p:spPr>
+          <a:xfrm>
+            <a:off x="2039112" y="2844102"/>
+            <a:ext cx="8229600" cy="1143000"/>
+          </a:xfrm>
+        </p:spPr>
+        <p:txBody>
+          <a:bodyPr>
+            <a:noAutofit/>
+          </a:bodyPr>
+          <a:lstStyle/>
+          <a:p>
+            <a:r>
+              <a:rPr lang="en-US" sz="6000" b="1" i="1" dirty="0" smtClean="0">
+                <a:solidFill>
+                  <a:schemeClr val="tx2"/>
+                </a:solidFill>
+                <a:latin typeface="Times New Roman" panose="02020603050405020304" pitchFamily="18" charset="0"/>
+                <a:cs typeface="Times New Roman" panose="02020603050405020304" pitchFamily="18" charset="0"/>
+              </a:rPr>
+              <a:t>THANK YOU</a:t>
+            </a:r>
+            <a:endParaRPr lang="en-IN" sz="6000" b="1" i="1" dirty="0">
+              <a:solidFill>
+                <a:schemeClr val="tx2"/>
+              </a:solidFill>
+              <a:latin typeface="Times New Roman" panose="02020603050405020304" pitchFamily="18" charset="0"/>
+              <a:cs typeface="Times New Roman" panose="02020603050405020304" pitchFamily="18" charset="0"/>
+            </a:endParaRPr>
+          </a:p>
+        </p:txBody>
+      </p:sp>
+    </p:spTree>
+    <p:extLst>
+      <p:ext uri="{BB962C8B-B14F-4D97-AF65-F5344CB8AC3E}">
+        <p14:creationId xmlns:p14="http://schemas.microsoft.com/office/powerpoint/2010/main" val="958501976"/>
+      </p:ext>
+    </p:extLst>
+  </p:cSld>
+  <p:clrMapOvr>
+    <a:masterClrMapping/>
+  </p:clrMapOvr>
 </p:sld>
 </file>
 
 <file path=ppt/theme/theme1.xml><?xml version="1.0" encoding="utf-8"?>
-<a:theme xmlns:a="http://schemas.openxmlformats.org/drawingml/2006/main" name="Office Theme">
+<a:theme xmlns:a="http://schemas.openxmlformats.org/drawingml/2006/main" name="Damask">
   <a:themeElements>
-    <a:clrScheme name="Office">
+    <a:clrScheme name="Damask">
       <a:dk1>
         <a:sysClr val="windowText" lastClr="000000"/>
       </a:dk1>
@@ -11488,39 +14118,39 @@
         <a:sysClr val="window" lastClr="FFFFFF"/>
       </a:lt1>
       <a:dk2>
-        <a:srgbClr val="1F497D"/>
+        <a:srgbClr val="2A5B7F"/>
       </a:dk2>
       <a:lt2>
-        <a:srgbClr val="EEECE1"/>
+        <a:srgbClr val="ABDAFC"/>
       </a:lt2>
       <a:accent1>
-        <a:srgbClr val="4F81BD"/>
+        <a:srgbClr val="9EC544"/>
       </a:accent1>
       <a:accent2>
-        <a:srgbClr val="C0504D"/>
+        <a:srgbClr val="50BEA3"/>
       </a:accent2>
       <a:accent3>
-        <a:srgbClr val="9BBB59"/>
+        <a:srgbClr val="4A9CCC"/>
       </a:accent3>
       <a:accent4>
-        <a:srgbClr val="8064A2"/>
+        <a:srgbClr val="9A66CA"/>
       </a:accent4>
       <a:accent5>
-        <a:srgbClr val="4BACC6"/>
+        <a:srgbClr val="C54F71"/>
       </a:accent5>
       <a:accent6>
-        <a:srgbClr val="F79646"/>
+        <a:srgbClr val="DE9C3C"/>
       </a:accent6>
       <a:hlink>
-        <a:srgbClr val="0000FF"/>
+        <a:srgbClr val="6BA9DA"/>
       </a:hlink>
       <a:folHlink>
-        <a:srgbClr val="800080"/>
+        <a:srgbClr val="A0BCD3"/>
       </a:folHlink>
     </a:clrScheme>
-    <a:fontScheme name="Office">
+    <a:fontScheme name="Damask">
       <a:majorFont>
-        <a:latin typeface="Calibri"/>
+        <a:latin typeface="Bookman Old Style" panose="02050604050505020204"/>
         <a:ea typeface=""/>
         <a:cs typeface=""/>
         <a:font script="Jpan" typeface="ＭＳ Ｐゴシック"/>
@@ -11555,7 +14185,7 @@
         <a:font script="Geor" typeface="Sylfaen"/>
       </a:majorFont>
       <a:minorFont>
-        <a:latin typeface="Calibri"/>
+        <a:latin typeface="Rockwell" panose="02060603020205020403"/>
         <a:ea typeface=""/>
         <a:cs typeface=""/>
         <a:font script="Jpan" typeface="ＭＳ Ｐゴシック"/>
@@ -11590,7 +14220,7 @@
         <a:font script="Geor" typeface="Sylfaen"/>
       </a:minorFont>
     </a:fontScheme>
-    <a:fmtScheme name="Office">
+    <a:fmtScheme name="Damask">
       <a:fillStyleLst>
         <a:solidFill>
           <a:schemeClr val="phClr"/>
@@ -11599,52 +14229,58 @@
           <a:gsLst>
             <a:gs pos="0">
               <a:schemeClr val="phClr">
-                <a:tint val="50000"/>
-                <a:satMod val="300000"/>
-              </a:schemeClr>
-            </a:gs>
-            <a:gs pos="35000">
-              <a:schemeClr val="phClr">
-                <a:tint val="37000"/>
-                <a:satMod val="300000"/>
+                <a:tint val="48000"/>
+                <a:satMod val="105000"/>
+                <a:lumMod val="110000"/>
               </a:schemeClr>
             </a:gs>
             <a:gs pos="100000">
               <a:schemeClr val="phClr">
-                <a:tint val="15000"/>
-                <a:satMod val="350000"/>
+                <a:tint val="78000"/>
+                <a:satMod val="109000"/>
+                <a:lumMod val="100000"/>
               </a:schemeClr>
             </a:gs>
           </a:gsLst>
-          <a:lin ang="16200000" scaled="1"/>
+          <a:lin ang="5400000" scaled="0"/>
         </a:gradFill>
         <a:gradFill rotWithShape="1">
           <a:gsLst>
             <a:gs pos="0">
               <a:schemeClr val="phClr">
-                <a:tint val="100000"/>
-                <a:shade val="100000"/>
+                <a:tint val="94000"/>
+                <a:satMod val="100000"/>
+                <a:lumMod val="104000"/>
+              </a:schemeClr>
+            </a:gs>
+            <a:gs pos="69000">
+              <a:schemeClr val="phClr">
+                <a:shade val="86000"/>
                 <a:satMod val="130000"/>
+                <a:lumMod val="102000"/>
               </a:schemeClr>
             </a:gs>
             <a:gs pos="100000">
               <a:schemeClr val="phClr">
-                <a:tint val="50000"/>
-                <a:shade val="100000"/>
-                <a:satMod val="350000"/>
+                <a:shade val="72000"/>
+                <a:satMod val="130000"/>
+                <a:lumMod val="100000"/>
               </a:schemeClr>
             </a:gs>
           </a:gsLst>
-          <a:lin ang="16200000" scaled="0"/>
+          <a:lin ang="5400000" scaled="0"/>
         </a:gradFill>
       </a:fillStyleLst>
       <a:lnStyleLst>
-        <a:ln w="9525" cap="flat" cmpd="sng" algn="ctr">
+        <a:ln w="12700" cap="flat" cmpd="sng" algn="ctr">
           <a:solidFill>
-            <a:schemeClr val="phClr">
-              <a:shade val="95000"/>
-              <a:satMod val="105000"/>
-            </a:schemeClr>
+            <a:schemeClr val="phClr"/>
+          </a:solidFill>
+          <a:prstDash val="solid"/>
+        </a:ln>
+        <a:ln w="19050" cap="flat" cmpd="sng" algn="ctr">
+          <a:solidFill>
+            <a:schemeClr val="phClr"/>
           </a:solidFill>
           <a:prstDash val="solid"/>
         </a:ln>
@@ -11654,37 +14290,25 @@
           </a:solidFill>
           <a:prstDash val="solid"/>
         </a:ln>
-        <a:ln w="38100" cap="flat" cmpd="sng" algn="ctr">
-          <a:solidFill>
-            <a:schemeClr val="phClr"/>
-          </a:solidFill>
-          <a:prstDash val="solid"/>
-        </a:ln>
       </a:lnStyleLst>
       <a:effectStyleLst>
         <a:effectStyle>
+          <a:effectLst/>
+        </a:effectStyle>
+        <a:effectStyle>
           <a:effectLst>
-            <a:outerShdw blurRad="40000" dist="20000" dir="5400000" rotWithShape="0">
+            <a:outerShdw blurRad="50800" dist="38100" dir="5400000" sy="96000" rotWithShape="0">
               <a:srgbClr val="000000">
-                <a:alpha val="38000"/>
+                <a:alpha val="54000"/>
               </a:srgbClr>
             </a:outerShdw>
           </a:effectLst>
         </a:effectStyle>
         <a:effectStyle>
           <a:effectLst>
-            <a:outerShdw blurRad="40000" dist="23000" dir="5400000" rotWithShape="0">
+            <a:outerShdw blurRad="76200" dist="38100" dir="5400000" algn="ctr" rotWithShape="0">
               <a:srgbClr val="000000">
-                <a:alpha val="35000"/>
-              </a:srgbClr>
-            </a:outerShdw>
-          </a:effectLst>
-        </a:effectStyle>
-        <a:effectStyle>
-          <a:effectLst>
-            <a:outerShdw blurRad="40000" dist="23000" dir="5400000" rotWithShape="0">
-              <a:srgbClr val="000000">
-                <a:alpha val="35000"/>
+                <a:alpha val="76000"/>
               </a:srgbClr>
             </a:outerShdw>
           </a:effectLst>
@@ -11692,12 +14316,10 @@
             <a:camera prst="orthographicFront">
               <a:rot lat="0" lon="0" rev="0"/>
             </a:camera>
-            <a:lightRig rig="threePt" dir="t">
-              <a:rot lat="0" lon="0" rev="1200000"/>
-            </a:lightRig>
+            <a:lightRig rig="balanced" dir="t"/>
           </a:scene3d>
-          <a:sp3d>
-            <a:bevelT w="63500" h="25400"/>
+          <a:sp3d prstMaterial="matte">
+            <a:bevelT w="25400" h="25400" prst="relaxedInset"/>
           </a:sp3d>
         </a:effectStyle>
       </a:effectStyleLst>
@@ -11705,94 +14327,38 @@
         <a:solidFill>
           <a:schemeClr val="phClr"/>
         </a:solidFill>
-        <a:gradFill rotWithShape="1">
-          <a:gsLst>
-            <a:gs pos="0">
+        <a:solidFill>
+          <a:schemeClr val="phClr">
+            <a:tint val="95000"/>
+            <a:satMod val="170000"/>
+          </a:schemeClr>
+        </a:solidFill>
+        <a:blipFill rotWithShape="1">
+          <a:blip xmlns:r="http://schemas.openxmlformats.org/officeDocument/2006/relationships" r:embed="rId1">
+            <a:duotone>
               <a:schemeClr val="phClr">
-                <a:tint val="40000"/>
-                <a:satMod val="350000"/>
+                <a:shade val="18000"/>
+                <a:satMod val="160000"/>
+                <a:lumMod val="28000"/>
               </a:schemeClr>
-            </a:gs>
-            <a:gs pos="40000">
               <a:schemeClr val="phClr">
-                <a:tint val="45000"/>
-                <a:shade val="99000"/>
-                <a:satMod val="350000"/>
+                <a:tint val="95000"/>
+                <a:satMod val="160000"/>
+                <a:lumMod val="116000"/>
               </a:schemeClr>
-            </a:gs>
-            <a:gs pos="100000">
-              <a:schemeClr val="phClr">
-                <a:shade val="20000"/>
-                <a:satMod val="255000"/>
-              </a:schemeClr>
-            </a:gs>
-          </a:gsLst>
-          <a:path path="circle">
-            <a:fillToRect l="50000" t="-80000" r="50000" b="180000"/>
-          </a:path>
-        </a:gradFill>
-        <a:gradFill rotWithShape="1">
-          <a:gsLst>
-            <a:gs pos="0">
-              <a:schemeClr val="phClr">
-                <a:tint val="80000"/>
-                <a:satMod val="300000"/>
-              </a:schemeClr>
-            </a:gs>
-            <a:gs pos="100000">
-              <a:schemeClr val="phClr">
-                <a:shade val="30000"/>
-                <a:satMod val="200000"/>
-              </a:schemeClr>
-            </a:gs>
-          </a:gsLst>
-          <a:path path="circle">
-            <a:fillToRect l="50000" t="50000" r="50000" b="50000"/>
-          </a:path>
-        </a:gradFill>
+            </a:duotone>
+          </a:blip>
+          <a:stretch/>
+        </a:blipFill>
       </a:bgFillStyleLst>
     </a:fmtScheme>
   </a:themeElements>
-  <a:objectDefaults>
-    <a:spDef>
-      <a:spPr/>
-      <a:bodyPr/>
-      <a:lstStyle/>
-      <a:style>
-        <a:lnRef idx="1">
-          <a:schemeClr val="accent1"/>
-        </a:lnRef>
-        <a:fillRef idx="3">
-          <a:schemeClr val="accent1"/>
-        </a:fillRef>
-        <a:effectRef idx="2">
-          <a:schemeClr val="accent1"/>
-        </a:effectRef>
-        <a:fontRef idx="minor">
-          <a:schemeClr val="lt1"/>
-        </a:fontRef>
-      </a:style>
-    </a:spDef>
-    <a:lnDef>
-      <a:spPr/>
-      <a:bodyPr/>
-      <a:lstStyle/>
-      <a:style>
-        <a:lnRef idx="2">
-          <a:schemeClr val="accent1"/>
-        </a:lnRef>
-        <a:fillRef idx="0">
-          <a:schemeClr val="accent1"/>
-        </a:fillRef>
-        <a:effectRef idx="1">
-          <a:schemeClr val="accent1"/>
-        </a:effectRef>
-        <a:fontRef idx="minor">
-          <a:schemeClr val="tx1"/>
-        </a:fontRef>
-      </a:style>
-    </a:lnDef>
-  </a:objectDefaults>
+  <a:objectDefaults/>
   <a:extraClrSchemeLst/>
+  <a:extLst>
+    <a:ext uri="{05A4C25C-085E-4340-85A3-A5531E510DB2}">
+      <thm15:themeFamily xmlns:thm15="http://schemas.microsoft.com/office/thememl/2012/main" name="Damask" id="{F9A299A0-33D0-4E0F-9F3F-7163E3744208}" vid="{746EEEEA-FB6A-406B-B510-531588D54811}"/>
+    </a:ext>
+  </a:extLst>
 </a:theme>
 </file>
</xml_diff>